<commit_message>
#Customer-wise only: case pages and Rings page removed; deck and docs to the customer flow
- Case page and Rings page/menu removed; Risk Lens actions moved to RiskLensController (/risk-lens)
- Customer links stay in each Risk Lens Network section, naming the linked customers
- A confirmed finding keeps blocking the loan case; only a dismissed one stops counting
- Deck: team AS FinTech Developer, customer flow, new snapshots; README, architecture, plan and video script updated
</commit_message>
<xml_diff>
--- a/Doc/FinRiskLens_AI_Builder_Cup_2026.pptx
+++ b/Doc/FinRiskLens_AI_Builder_Cup_2026.pptx
@@ -19,8 +19,6 @@
     <p:sldId id="265" r:id="rId15"/>
     <p:sldId id="266" r:id="rId16"/>
     <p:sldId id="274" r:id="rId30"/>
-    <p:sldId id="273" r:id="rId29"/>
-    <p:sldId id="272" r:id="rId28"/>
     <p:sldId id="267" r:id="rId17"/>
     <p:sldId id="268" r:id="rId18"/>
     <p:sldId id="269" r:id="rId19"/>
@@ -796,7 +794,7 @@
           <a:lstStyle/>
           <a:p>
             <a:r>
-              <a:t>FinRiskLens — evidence-based fraud detection and risk analysis for lending, built on Google Cloud by team ASM FinTech Developer.</a:t>
+              <a:t>FinRiskLens — evidence-based fraud detection and risk analysis for MSME lending, built on Google Cloud by team AS FinTech Developer.</a:t>
             </a:r>
           </a:p>
         </p:txBody>
@@ -885,7 +883,7 @@
           <a:lstStyle/>
           <a:p>
             <a:r>
-              <a:t>All figures are planning estimates, not quotes. Gemini usage scales with pages read and investigations run.</a:t>
+              <a:t>All figures are planning estimates for budgeting. Gemini usage scales with pages read, investigations run and credit decisions made.</a:t>
             </a:r>
           </a:p>
         </p:txBody>
@@ -1073,7 +1071,7 @@
           <a:lstStyle/>
           <a:p>
             <a:r>
-              <a:t>Extraction accuracy: two consecutive live runs on 14 cases (17 documents, 1,298 rows) scored 99.8% and 100%; the 6 ring cases scored 428/428. The eval also caught a model drift (95.6%) that day-first date guidance and an arithmetic-triggered re-read fixed.</a:t>
+              <a:t>Extraction accuracy: two consecutive live runs on 14 scenarios (17 documents, 1,298 rows) scored 99.8% and 100%; the 6 linked-applicant scenarios scored 428/428. The eval also caught a model drift (95.6%) that day-first date guidance and an arithmetic-triggered re-read fixed.</a:t>
             </a:r>
           </a:p>
         </p:txBody>
@@ -1845,7 +1843,7 @@
           <a:lstStyle/>
           <a:p>
             <a:r>
-              <a:t>Steps 2–6 run off the request thread in a background worker; the case page refreshes until they finish.</a:t>
+              <a:t>Steps 2–5 run in a background worker whenever a customer shares a source or uploads a document; the Risk Lens refreshes until they finish. Step 7 runs only for a Clear customer — a confirmed finding blocks it — and only an accepted Approve can be sent.</a:t>
             </a:r>
           </a:p>
         </p:txBody>
@@ -2033,7 +2031,7 @@
           <a:lstStyle/>
           <a:p>
             <a:r>
-              <a:t>Applicant documents are stored, read and embedded in Mumbai; only the Pro investigator, which sees extracted facts, runs on the global endpoint.</a:t>
+              <a:t>Customer documents are stored, read and embedded in Mumbai; only Gemini Pro (investigator and credit decision) and the Flash reranker run on the global endpoint, and Pro sees extracted facts, never the files.</a:t>
             </a:r>
           </a:p>
         </p:txBody>
@@ -6889,7 +6887,7 @@
                 <a:cs typeface="Google Sans Flex"/>
                 <a:sym typeface="Google Sans Flex"/>
               </a:rPr>
-              <a:t>ASM FinTech Developer</a:t>
+              <a:t>AS FinTech Developer</a:t>
             </a:r>
             <a:endParaRPr sz="1800">
               <a:latin typeface="Google Sans Flex"/>
@@ -6972,7 +6970,7 @@
                 <a:cs typeface="Google Sans Flex"/>
                 <a:sym typeface="Google Sans Flex"/>
               </a:rPr>
-              <a:t>FinRiskLens — evidence-based detection of tampered loan documents and the fraud rings behind them</a:t>
+              <a:t>FinRiskLens — fraud detection and risk analysis for every MSME customer, from shared data to a grounded AI credit decision</a:t>
             </a:r>
             <a:endParaRPr sz="1800">
               <a:latin typeface="Google Sans Flex"/>
@@ -7292,14 +7290,14 @@
                 </a:solidFill>
                 <a:latin typeface="Arial"/>
               </a:rPr>
-              <a:t>What FinRiskLens does, with a real finding</a:t>
+              <a:t>Customers start here with their Udyam number</a:t>
             </a:r>
           </a:p>
         </p:txBody>
       </p:sp>
       <p:pic>
         <p:nvPicPr>
-          <p:cNvPr id="138" name="snap_home" descr="home.png"/>
+          <p:cNvPr id="138" name="snap_home_v2" descr="home_v2.png"/>
           <p:cNvPicPr>
             <a:picLocks noChangeAspect="1"/>
           </p:cNvPicPr>
@@ -7314,7 +7312,7 @@
         <p:spPr>
           <a:xfrm>
             <a:off x="320040" y="1920240"/>
-            <a:ext cx="4160520" cy="2869145"/>
+            <a:ext cx="4160520" cy="2626328"/>
           </a:xfrm>
           <a:prstGeom prst="rect">
             <a:avLst/>
@@ -7363,7 +7361,7 @@
                 </a:solidFill>
                 <a:latin typeface="Arial"/>
               </a:rPr>
-              <a:t>Opening a case</a:t>
+              <a:t>Customers</a:t>
             </a:r>
           </a:p>
         </p:txBody>
@@ -7405,14 +7403,14 @@
                 </a:solidFill>
                 <a:latin typeface="Arial"/>
               </a:rPr>
-              <a:t>Application details, Udyam number and the documents</a:t>
+              <a:t>A risk status for every customer</a:t>
             </a:r>
           </a:p>
         </p:txBody>
       </p:sp>
       <p:pic>
         <p:nvPicPr>
-          <p:cNvPr id="141" name="snap_new_case" descr="new_case.png"/>
+          <p:cNvPr id="141" name="snap_customers_v2" descr="customers_v2.png"/>
           <p:cNvPicPr>
             <a:picLocks noChangeAspect="1"/>
           </p:cNvPicPr>
@@ -7427,7 +7425,7 @@
         <p:spPr>
           <a:xfrm>
             <a:off x="4663440" y="1920240"/>
-            <a:ext cx="4160520" cy="2452572"/>
+            <a:ext cx="4160520" cy="2661043"/>
           </a:xfrm>
           <a:prstGeom prst="rect">
             <a:avLst/>
@@ -7651,7 +7649,7 @@
                 </a:solidFill>
                 <a:latin typeface="Arial"/>
               </a:rPr>
-              <a:t>Statement vs the bank's own record</a:t>
+              <a:t>One page per customer</a:t>
             </a:r>
           </a:p>
         </p:txBody>
@@ -7693,14 +7691,14 @@
                 </a:solidFill>
                 <a:latin typeface="Arial"/>
               </a:rPr>
-              <a:t>A forgery that passes every arithmetic check</a:t>
+              <a:t>Opens on the Risk Lens; every source in its own tab</a:t>
             </a:r>
           </a:p>
         </p:txBody>
       </p:sp>
       <p:pic>
         <p:nvPicPr>
-          <p:cNvPr id="138" name="snap_t04_aa" descr="t04_aa.png"/>
+          <p:cNvPr id="138" name="snap_customer_top_v2" descr="customer_top_v2.png"/>
           <p:cNvPicPr>
             <a:picLocks noChangeAspect="1"/>
           </p:cNvPicPr>
@@ -7715,7 +7713,7 @@
         <p:spPr>
           <a:xfrm>
             <a:off x="320040" y="1920240"/>
-            <a:ext cx="4160520" cy="2418302"/>
+            <a:ext cx="4160520" cy="2652332"/>
           </a:xfrm>
           <a:prstGeom prst="rect">
             <a:avLst/>
@@ -7764,7 +7762,7 @@
                 </a:solidFill>
                 <a:latin typeface="Arial"/>
               </a:rPr>
-              <a:t>The document's own arithmetic</a:t>
+              <a:t>Clear → loan case</a:t>
             </a:r>
           </a:p>
         </p:txBody>
@@ -7806,14 +7804,14 @@
                 </a:solidFill>
                 <a:latin typeface="Arial"/>
               </a:rPr>
-              <a:t>A balance break and page totals that disagree</a:t>
+              <a:t>Sections by source; the AI credit decision once Clear</a:t>
             </a:r>
           </a:p>
         </p:txBody>
       </p:sp>
       <p:pic>
         <p:nvPicPr>
-          <p:cNvPr id="141" name="snap_t01_tamper" descr="t01_tamper.png"/>
+          <p:cNvPr id="141" name="snap_loan_case_v2" descr="loan_case_v2.png"/>
           <p:cNvPicPr>
             <a:picLocks noChangeAspect="1"/>
           </p:cNvPicPr>
@@ -7828,809 +7826,7 @@
         <p:spPr>
           <a:xfrm>
             <a:off x="4663440" y="1920240"/>
-            <a:ext cx="4160520" cy="2418302"/>
-          </a:xfrm>
-          <a:prstGeom prst="rect">
-            <a:avLst/>
-          </a:prstGeom>
-          <a:ln w="9525">
-            <a:solidFill>
-              <a:srgbClr val="DADCE0"/>
-            </a:solidFill>
-          </a:ln>
-        </p:spPr>
-      </p:pic>
-    </p:spTree>
-  </p:cSld>
-  <p:clrMapOvr>
-    <a:masterClrMapping/>
-  </p:clrMapOvr>
-</p:sld>
-</file>
-
-<file path=ppt/slides/slide12.xml><?xml version="1.0" encoding="utf-8"?>
-<p:sld xmlns:a="http://schemas.openxmlformats.org/drawingml/2006/main" xmlns:r="http://schemas.openxmlformats.org/officeDocument/2006/relationships" xmlns:mc="http://schemas.openxmlformats.org/markup-compatibility/2006" xmlns:mv="urn:schemas-microsoft-com:mac:vml" xmlns:p="http://schemas.openxmlformats.org/presentationml/2006/main" xmlns:c="http://schemas.openxmlformats.org/drawingml/2006/chart" xmlns:dgm="http://schemas.openxmlformats.org/drawingml/2006/diagram" xmlns:o="urn:schemas-microsoft-com:office:office" xmlns:v="urn:schemas-microsoft-com:vml" xmlns:pvml="urn:schemas-microsoft-com:office:powerpoint" xmlns:com="http://schemas.openxmlformats.org/drawingml/2006/compatibility" xmlns:p14="http://schemas.microsoft.com/office/powerpoint/2010/main" xmlns:p15="http://schemas.microsoft.com/office/powerpoint/2012/main" xmlns:ahyp="http://schemas.microsoft.com/office/drawing/2018/hyperlinkcolor">
-  <p:cSld>
-    <p:spTree>
-      <p:nvGrpSpPr>
-        <p:cNvPr id="131" name="Shape 131"/>
-        <p:cNvGrpSpPr/>
-        <p:nvPr/>
-      </p:nvGrpSpPr>
-      <p:grpSpPr>
-        <a:xfrm>
-          <a:off x="0" y="0"/>
-          <a:ext cx="0" cy="0"/>
-          <a:chOff x="0" y="0"/>
-          <a:chExt cx="0" cy="0"/>
-        </a:xfrm>
-      </p:grpSpPr>
-      <p:pic>
-        <p:nvPicPr>
-          <p:cNvPr id="132" name="Google Shape;132;p23" title="Frame 144.png"/>
-          <p:cNvPicPr preferRelativeResize="0"/>
-          <p:nvPr/>
-        </p:nvPicPr>
-        <p:blipFill rotWithShape="1">
-          <a:blip r:embed="rId3">
-            <a:alphaModFix/>
-          </a:blip>
-          <a:srcRect b="98001" l="0" r="0" t="0"/>
-          <a:stretch/>
-        </p:blipFill>
-        <p:spPr>
-          <a:xfrm>
-            <a:off x="0" y="5093562"/>
-            <a:ext cx="9144000" cy="54275"/>
-          </a:xfrm>
-          <a:prstGeom prst="rect">
-            <a:avLst/>
-          </a:prstGeom>
-          <a:noFill/>
-          <a:ln>
-            <a:noFill/>
-          </a:ln>
-        </p:spPr>
-      </p:pic>
-      <p:pic>
-        <p:nvPicPr>
-          <p:cNvPr id="133" name="Google Shape;133;p23" title="Group 427319979.png"/>
-          <p:cNvPicPr preferRelativeResize="0"/>
-          <p:nvPr/>
-        </p:nvPicPr>
-        <p:blipFill>
-          <a:blip r:embed="rId4">
-            <a:alphaModFix/>
-          </a:blip>
-          <a:stretch>
-            <a:fillRect/>
-          </a:stretch>
-        </p:blipFill>
-        <p:spPr>
-          <a:xfrm>
-            <a:off x="0" y="1"/>
-            <a:ext cx="9144000" cy="507359"/>
-          </a:xfrm>
-          <a:prstGeom prst="rect">
-            <a:avLst/>
-          </a:prstGeom>
-          <a:noFill/>
-          <a:ln>
-            <a:noFill/>
-          </a:ln>
-        </p:spPr>
-      </p:pic>
-      <p:sp>
-        <p:nvSpPr>
-          <p:cNvPr id="134" name="Google Shape;134;p23"/>
-          <p:cNvSpPr/>
-          <p:nvPr/>
-        </p:nvSpPr>
-        <p:spPr>
-          <a:xfrm>
-            <a:off x="-29250" y="5071875"/>
-            <a:ext cx="9173400" cy="97800"/>
-          </a:xfrm>
-          <a:prstGeom prst="rect">
-            <a:avLst/>
-          </a:prstGeom>
-          <a:solidFill>
-            <a:schemeClr val="dk1"/>
-          </a:solidFill>
-          <a:ln>
-            <a:noFill/>
-          </a:ln>
-        </p:spPr>
-        <p:txBody>
-          <a:bodyPr anchorCtr="0" anchor="ctr" bIns="91425" lIns="91425" spcFirstLastPara="1" rIns="91425" wrap="square" tIns="91425">
-            <a:noAutofit/>
-          </a:bodyPr>
-          <a:lstStyle/>
-          <a:p>
-            <a:pPr indent="0" lvl="0" marL="0" rtl="0" algn="ctr">
-              <a:spcBef>
-                <a:spcPts val="0"/>
-              </a:spcBef>
-              <a:spcAft>
-                <a:spcPts val="0"/>
-              </a:spcAft>
-              <a:buNone/>
-            </a:pPr>
-            <a:r>
-              <a:t/>
-            </a:r>
-            <a:endParaRPr/>
-          </a:p>
-        </p:txBody>
-      </p:sp>
-      <p:sp>
-        <p:nvSpPr>
-          <p:cNvPr id="135" name="Google Shape;135;p23"/>
-          <p:cNvSpPr txBox="1"/>
-          <p:nvPr/>
-        </p:nvSpPr>
-        <p:spPr>
-          <a:xfrm>
-            <a:off x="265350" y="663825"/>
-            <a:ext cx="8943000" cy="561900"/>
-          </a:xfrm>
-          <a:prstGeom prst="rect">
-            <a:avLst/>
-          </a:prstGeom>
-          <a:noFill/>
-          <a:ln>
-            <a:noFill/>
-          </a:ln>
-        </p:spPr>
-        <p:txBody>
-          <a:bodyPr anchorCtr="0" anchor="t" bIns="91425" lIns="91425" spcFirstLastPara="1" rIns="91425" wrap="square" tIns="91425">
-            <a:noAutofit/>
-          </a:bodyPr>
-          <a:lstStyle/>
-          <a:p>
-            <a:pPr indent="0" lvl="0" marL="0" rtl="0" algn="l">
-              <a:spcBef>
-                <a:spcPts val="0"/>
-              </a:spcBef>
-              <a:spcAft>
-                <a:spcPts val="0"/>
-              </a:spcAft>
-              <a:buNone/>
-            </a:pPr>
-            <a:r>
-              <a:rPr lang="en-GB" sz="1600">
-                <a:latin typeface="Google Sans Flex Medium"/>
-                <a:ea typeface="Google Sans Flex Medium"/>
-                <a:cs typeface="Google Sans Flex Medium"/>
-                <a:sym typeface="Google Sans Flex Medium"/>
-              </a:rPr>
-              <a:t>Snapshots of the prototype</a:t>
-            </a:r>
-            <a:endParaRPr sz="1600">
-              <a:latin typeface="Google Sans Flex Medium"/>
-              <a:ea typeface="Google Sans Flex Medium"/>
-              <a:cs typeface="Google Sans Flex Medium"/>
-              <a:sym typeface="Google Sans Flex Medium"/>
-            </a:endParaRPr>
-          </a:p>
-        </p:txBody>
-      </p:sp>
-      <p:sp>
-        <p:nvSpPr>
-          <p:cNvPr id="136" name="TextBox 135"/>
-          <p:cNvSpPr txBox="1"/>
-          <p:nvPr/>
-        </p:nvSpPr>
-        <p:spPr>
-          <a:xfrm>
-            <a:off x="320040" y="1371600"/>
-            <a:ext cx="4160520" cy="246888"/>
-          </a:xfrm>
-          <a:prstGeom prst="rect">
-            <a:avLst/>
-          </a:prstGeom>
-          <a:noFill/>
-        </p:spPr>
-        <p:txBody>
-          <a:bodyPr wrap="square" anchor="t" lIns="0" rIns="0" tIns="0" bIns="0">
-            <a:noAutofit/>
-          </a:bodyPr>
-          <a:lstStyle/>
-          <a:p>
-            <a:pPr algn="l">
-              <a:spcBef>
-                <a:spcPts val="0"/>
-              </a:spcBef>
-              <a:spcAft>
-                <a:spcPts val="300"/>
-              </a:spcAft>
-            </a:pPr>
-            <a:r>
-              <a:rPr sz="1150" b="1" i="0">
-                <a:solidFill>
-                  <a:srgbClr val="202124"/>
-                </a:solidFill>
-                <a:latin typeface="Arial"/>
-              </a:rPr>
-              <a:t>AI investigator, grounded</a:t>
-            </a:r>
-          </a:p>
-        </p:txBody>
-      </p:sp>
-      <p:sp>
-        <p:nvSpPr>
-          <p:cNvPr id="137" name="TextBox 136"/>
-          <p:cNvSpPr txBox="1"/>
-          <p:nvPr/>
-        </p:nvSpPr>
-        <p:spPr>
-          <a:xfrm>
-            <a:off x="320040" y="1609344"/>
-            <a:ext cx="4160520" cy="228600"/>
-          </a:xfrm>
-          <a:prstGeom prst="rect">
-            <a:avLst/>
-          </a:prstGeom>
-          <a:noFill/>
-        </p:spPr>
-        <p:txBody>
-          <a:bodyPr wrap="square" anchor="t" lIns="0" rIns="0" tIns="0" bIns="0">
-            <a:noAutofit/>
-          </a:bodyPr>
-          <a:lstStyle/>
-          <a:p>
-            <a:pPr algn="l">
-              <a:spcBef>
-                <a:spcPts val="0"/>
-              </a:spcBef>
-              <a:spcAft>
-                <a:spcPts val="300"/>
-              </a:spcAft>
-            </a:pPr>
-            <a:r>
-              <a:rPr sz="1000" b="0" i="0">
-                <a:solidFill>
-                  <a:srgbClr val="5F6368"/>
-                </a:solidFill>
-                <a:latin typeface="Arial"/>
-              </a:rPr>
-              <a:t>Undeclared EMIs and loan stacking, cited to rows and policy</a:t>
-            </a:r>
-          </a:p>
-        </p:txBody>
-      </p:sp>
-      <p:pic>
-        <p:nvPicPr>
-          <p:cNvPr id="138" name="snap_a01_ai" descr="a01_ai.png"/>
-          <p:cNvPicPr>
-            <a:picLocks noChangeAspect="1"/>
-          </p:cNvPicPr>
-          <p:nvPr/>
-        </p:nvPicPr>
-        <p:blipFill>
-          <a:blip r:embed="rId2"/>
-          <a:stretch>
-            <a:fillRect/>
-          </a:stretch>
-        </p:blipFill>
-        <p:spPr>
-          <a:xfrm>
-            <a:off x="320040" y="1920240"/>
-            <a:ext cx="4160520" cy="2418302"/>
-          </a:xfrm>
-          <a:prstGeom prst="rect">
-            <a:avLst/>
-          </a:prstGeom>
-          <a:ln w="9525">
-            <a:solidFill>
-              <a:srgbClr val="DADCE0"/>
-            </a:solidFill>
-          </a:ln>
-        </p:spPr>
-      </p:pic>
-      <p:sp>
-        <p:nvSpPr>
-          <p:cNvPr id="139" name="TextBox 138"/>
-          <p:cNvSpPr txBox="1"/>
-          <p:nvPr/>
-        </p:nvSpPr>
-        <p:spPr>
-          <a:xfrm>
-            <a:off x="4663440" y="1371600"/>
-            <a:ext cx="4160520" cy="246888"/>
-          </a:xfrm>
-          <a:prstGeom prst="rect">
-            <a:avLst/>
-          </a:prstGeom>
-          <a:noFill/>
-        </p:spPr>
-        <p:txBody>
-          <a:bodyPr wrap="square" anchor="t" lIns="0" rIns="0" tIns="0" bIns="0">
-            <a:noAutofit/>
-          </a:bodyPr>
-          <a:lstStyle/>
-          <a:p>
-            <a:pPr algn="l">
-              <a:spcBef>
-                <a:spcPts val="0"/>
-              </a:spcBef>
-              <a:spcAft>
-                <a:spcPts val="300"/>
-              </a:spcAft>
-            </a:pPr>
-            <a:r>
-              <a:rPr sz="1150" b="1" i="0">
-                <a:solidFill>
-                  <a:srgbClr val="202124"/>
-                </a:solidFill>
-                <a:latin typeface="Arial"/>
-              </a:rPr>
-              <a:t>Verification sources</a:t>
-            </a:r>
-          </a:p>
-        </p:txBody>
-      </p:sp>
-      <p:sp>
-        <p:nvSpPr>
-          <p:cNvPr id="140" name="TextBox 139"/>
-          <p:cNvSpPr txBox="1"/>
-          <p:nvPr/>
-        </p:nvSpPr>
-        <p:spPr>
-          <a:xfrm>
-            <a:off x="4663440" y="1609344"/>
-            <a:ext cx="4160520" cy="228600"/>
-          </a:xfrm>
-          <a:prstGeom prst="rect">
-            <a:avLst/>
-          </a:prstGeom>
-          <a:noFill/>
-        </p:spPr>
-        <p:txBody>
-          <a:bodyPr wrap="square" anchor="t" lIns="0" rIns="0" tIns="0" bIns="0">
-            <a:noAutofit/>
-          </a:bodyPr>
-          <a:lstStyle/>
-          <a:p>
-            <a:pPr algn="l">
-              <a:spcBef>
-                <a:spcPts val="0"/>
-              </a:spcBef>
-              <a:spcAft>
-                <a:spcPts val="300"/>
-              </a:spcAft>
-            </a:pPr>
-            <a:r>
-              <a:rPr sz="1000" b="0" i="0">
-                <a:solidFill>
-                  <a:srgbClr val="5F6368"/>
-                </a:solidFill>
-                <a:latin typeface="Arial"/>
-              </a:rPr>
-              <a:t>Udyam, GST, Account Aggregator, ITR and MCA per MSME</a:t>
-            </a:r>
-          </a:p>
-        </p:txBody>
-      </p:sp>
-      <p:pic>
-        <p:nvPicPr>
-          <p:cNvPr id="141" name="snap_customer360" descr="customer360.png"/>
-          <p:cNvPicPr>
-            <a:picLocks noChangeAspect="1"/>
-          </p:cNvPicPr>
-          <p:nvPr/>
-        </p:nvPicPr>
-        <p:blipFill>
-          <a:blip r:embed="rId5"/>
-          <a:stretch>
-            <a:fillRect/>
-          </a:stretch>
-        </p:blipFill>
-        <p:spPr>
-          <a:xfrm>
-            <a:off x="4663440" y="1920240"/>
-            <a:ext cx="4160520" cy="2400500"/>
-          </a:xfrm>
-          <a:prstGeom prst="rect">
-            <a:avLst/>
-          </a:prstGeom>
-          <a:ln w="9525">
-            <a:solidFill>
-              <a:srgbClr val="DADCE0"/>
-            </a:solidFill>
-          </a:ln>
-        </p:spPr>
-      </p:pic>
-    </p:spTree>
-  </p:cSld>
-  <p:clrMapOvr>
-    <a:masterClrMapping/>
-  </p:clrMapOvr>
-</p:sld>
-</file>
-
-<file path=ppt/slides/slide13.xml><?xml version="1.0" encoding="utf-8"?>
-<p:sld xmlns:a="http://schemas.openxmlformats.org/drawingml/2006/main" xmlns:r="http://schemas.openxmlformats.org/officeDocument/2006/relationships" xmlns:mc="http://schemas.openxmlformats.org/markup-compatibility/2006" xmlns:mv="urn:schemas-microsoft-com:mac:vml" xmlns:p="http://schemas.openxmlformats.org/presentationml/2006/main" xmlns:c="http://schemas.openxmlformats.org/drawingml/2006/chart" xmlns:dgm="http://schemas.openxmlformats.org/drawingml/2006/diagram" xmlns:o="urn:schemas-microsoft-com:office:office" xmlns:v="urn:schemas-microsoft-com:vml" xmlns:pvml="urn:schemas-microsoft-com:office:powerpoint" xmlns:com="http://schemas.openxmlformats.org/drawingml/2006/compatibility" xmlns:p14="http://schemas.microsoft.com/office/powerpoint/2010/main" xmlns:p15="http://schemas.microsoft.com/office/powerpoint/2012/main" xmlns:ahyp="http://schemas.microsoft.com/office/drawing/2018/hyperlinkcolor">
-  <p:cSld>
-    <p:spTree>
-      <p:nvGrpSpPr>
-        <p:cNvPr id="131" name="Shape 131"/>
-        <p:cNvGrpSpPr/>
-        <p:nvPr/>
-      </p:nvGrpSpPr>
-      <p:grpSpPr>
-        <a:xfrm>
-          <a:off x="0" y="0"/>
-          <a:ext cx="0" cy="0"/>
-          <a:chOff x="0" y="0"/>
-          <a:chExt cx="0" cy="0"/>
-        </a:xfrm>
-      </p:grpSpPr>
-      <p:pic>
-        <p:nvPicPr>
-          <p:cNvPr id="132" name="Google Shape;132;p23" title="Frame 144.png"/>
-          <p:cNvPicPr preferRelativeResize="0"/>
-          <p:nvPr/>
-        </p:nvPicPr>
-        <p:blipFill rotWithShape="1">
-          <a:blip r:embed="rId3">
-            <a:alphaModFix/>
-          </a:blip>
-          <a:srcRect b="98001" l="0" r="0" t="0"/>
-          <a:stretch/>
-        </p:blipFill>
-        <p:spPr>
-          <a:xfrm>
-            <a:off x="0" y="5093562"/>
-            <a:ext cx="9144000" cy="54275"/>
-          </a:xfrm>
-          <a:prstGeom prst="rect">
-            <a:avLst/>
-          </a:prstGeom>
-          <a:noFill/>
-          <a:ln>
-            <a:noFill/>
-          </a:ln>
-        </p:spPr>
-      </p:pic>
-      <p:pic>
-        <p:nvPicPr>
-          <p:cNvPr id="133" name="Google Shape;133;p23" title="Group 427319979.png"/>
-          <p:cNvPicPr preferRelativeResize="0"/>
-          <p:nvPr/>
-        </p:nvPicPr>
-        <p:blipFill>
-          <a:blip r:embed="rId4">
-            <a:alphaModFix/>
-          </a:blip>
-          <a:stretch>
-            <a:fillRect/>
-          </a:stretch>
-        </p:blipFill>
-        <p:spPr>
-          <a:xfrm>
-            <a:off x="0" y="1"/>
-            <a:ext cx="9144000" cy="507359"/>
-          </a:xfrm>
-          <a:prstGeom prst="rect">
-            <a:avLst/>
-          </a:prstGeom>
-          <a:noFill/>
-          <a:ln>
-            <a:noFill/>
-          </a:ln>
-        </p:spPr>
-      </p:pic>
-      <p:sp>
-        <p:nvSpPr>
-          <p:cNvPr id="134" name="Google Shape;134;p23"/>
-          <p:cNvSpPr/>
-          <p:nvPr/>
-        </p:nvSpPr>
-        <p:spPr>
-          <a:xfrm>
-            <a:off x="-29250" y="5071875"/>
-            <a:ext cx="9173400" cy="97800"/>
-          </a:xfrm>
-          <a:prstGeom prst="rect">
-            <a:avLst/>
-          </a:prstGeom>
-          <a:solidFill>
-            <a:schemeClr val="dk1"/>
-          </a:solidFill>
-          <a:ln>
-            <a:noFill/>
-          </a:ln>
-        </p:spPr>
-        <p:txBody>
-          <a:bodyPr anchorCtr="0" anchor="ctr" bIns="91425" lIns="91425" spcFirstLastPara="1" rIns="91425" wrap="square" tIns="91425">
-            <a:noAutofit/>
-          </a:bodyPr>
-          <a:lstStyle/>
-          <a:p>
-            <a:pPr indent="0" lvl="0" marL="0" rtl="0" algn="ctr">
-              <a:spcBef>
-                <a:spcPts val="0"/>
-              </a:spcBef>
-              <a:spcAft>
-                <a:spcPts val="0"/>
-              </a:spcAft>
-              <a:buNone/>
-            </a:pPr>
-            <a:r>
-              <a:t/>
-            </a:r>
-            <a:endParaRPr/>
-          </a:p>
-        </p:txBody>
-      </p:sp>
-      <p:sp>
-        <p:nvSpPr>
-          <p:cNvPr id="135" name="Google Shape;135;p23"/>
-          <p:cNvSpPr txBox="1"/>
-          <p:nvPr/>
-        </p:nvSpPr>
-        <p:spPr>
-          <a:xfrm>
-            <a:off x="265350" y="663825"/>
-            <a:ext cx="8943000" cy="561900"/>
-          </a:xfrm>
-          <a:prstGeom prst="rect">
-            <a:avLst/>
-          </a:prstGeom>
-          <a:noFill/>
-          <a:ln>
-            <a:noFill/>
-          </a:ln>
-        </p:spPr>
-        <p:txBody>
-          <a:bodyPr anchorCtr="0" anchor="t" bIns="91425" lIns="91425" spcFirstLastPara="1" rIns="91425" wrap="square" tIns="91425">
-            <a:noAutofit/>
-          </a:bodyPr>
-          <a:lstStyle/>
-          <a:p>
-            <a:pPr indent="0" lvl="0" marL="0" rtl="0" algn="l">
-              <a:spcBef>
-                <a:spcPts val="0"/>
-              </a:spcBef>
-              <a:spcAft>
-                <a:spcPts val="0"/>
-              </a:spcAft>
-              <a:buNone/>
-            </a:pPr>
-            <a:r>
-              <a:rPr lang="en-GB" sz="1600">
-                <a:latin typeface="Google Sans Flex Medium"/>
-                <a:ea typeface="Google Sans Flex Medium"/>
-                <a:cs typeface="Google Sans Flex Medium"/>
-                <a:sym typeface="Google Sans Flex Medium"/>
-              </a:rPr>
-              <a:t>Snapshots of the prototype</a:t>
-            </a:r>
-            <a:endParaRPr sz="1600">
-              <a:latin typeface="Google Sans Flex Medium"/>
-              <a:ea typeface="Google Sans Flex Medium"/>
-              <a:cs typeface="Google Sans Flex Medium"/>
-              <a:sym typeface="Google Sans Flex Medium"/>
-            </a:endParaRPr>
-          </a:p>
-        </p:txBody>
-      </p:sp>
-      <p:sp>
-        <p:nvSpPr>
-          <p:cNvPr id="136" name="TextBox 135"/>
-          <p:cNvSpPr txBox="1"/>
-          <p:nvPr/>
-        </p:nvSpPr>
-        <p:spPr>
-          <a:xfrm>
-            <a:off x="320040" y="1371600"/>
-            <a:ext cx="4160520" cy="246888"/>
-          </a:xfrm>
-          <a:prstGeom prst="rect">
-            <a:avLst/>
-          </a:prstGeom>
-          <a:noFill/>
-        </p:spPr>
-        <p:txBody>
-          <a:bodyPr wrap="square" anchor="t" lIns="0" rIns="0" tIns="0" bIns="0">
-            <a:noAutofit/>
-          </a:bodyPr>
-          <a:lstStyle/>
-          <a:p>
-            <a:pPr algn="l">
-              <a:spcBef>
-                <a:spcPts val="0"/>
-              </a:spcBef>
-              <a:spcAft>
-                <a:spcPts val="300"/>
-              </a:spcAft>
-            </a:pPr>
-            <a:r>
-              <a:rPr sz="1150" b="1" i="0">
-                <a:solidFill>
-                  <a:srgbClr val="202124"/>
-                </a:solidFill>
-                <a:latin typeface="Arial"/>
-              </a:rPr>
-              <a:t>Rings</a:t>
-            </a:r>
-          </a:p>
-        </p:txBody>
-      </p:sp>
-      <p:sp>
-        <p:nvSpPr>
-          <p:cNvPr id="137" name="TextBox 136"/>
-          <p:cNvSpPr txBox="1"/>
-          <p:nvPr/>
-        </p:nvSpPr>
-        <p:spPr>
-          <a:xfrm>
-            <a:off x="320040" y="1609344"/>
-            <a:ext cx="4160520" cy="228600"/>
-          </a:xfrm>
-          <a:prstGeom prst="rect">
-            <a:avLst/>
-          </a:prstGeom>
-          <a:noFill/>
-        </p:spPr>
-        <p:txBody>
-          <a:bodyPr wrap="square" anchor="t" lIns="0" rIns="0" tIns="0" bIns="0">
-            <a:noAutofit/>
-          </a:bodyPr>
-          <a:lstStyle/>
-          <a:p>
-            <a:pPr algn="l">
-              <a:spcBef>
-                <a:spcPts val="0"/>
-              </a:spcBef>
-              <a:spcAft>
-                <a:spcPts val="300"/>
-              </a:spcAft>
-            </a:pPr>
-            <a:r>
-              <a:rPr sz="1000" b="0" i="0">
-                <a:solidFill>
-                  <a:srgbClr val="5F6368"/>
-                </a:solidFill>
-                <a:latin typeface="Arial"/>
-              </a:rPr>
-              <a:t>One template claiming five issuers; one salary account</a:t>
-            </a:r>
-          </a:p>
-        </p:txBody>
-      </p:sp>
-      <p:pic>
-        <p:nvPicPr>
-          <p:cNvPr id="138" name="snap_rings" descr="rings.png"/>
-          <p:cNvPicPr>
-            <a:picLocks noChangeAspect="1"/>
-          </p:cNvPicPr>
-          <p:nvPr/>
-        </p:nvPicPr>
-        <p:blipFill>
-          <a:blip r:embed="rId2"/>
-          <a:stretch>
-            <a:fillRect/>
-          </a:stretch>
-        </p:blipFill>
-        <p:spPr>
-          <a:xfrm>
-            <a:off x="320040" y="1920240"/>
-            <a:ext cx="4160520" cy="2452572"/>
-          </a:xfrm>
-          <a:prstGeom prst="rect">
-            <a:avLst/>
-          </a:prstGeom>
-          <a:ln w="9525">
-            <a:solidFill>
-              <a:srgbClr val="DADCE0"/>
-            </a:solidFill>
-          </a:ln>
-        </p:spPr>
-      </p:pic>
-      <p:sp>
-        <p:nvSpPr>
-          <p:cNvPr id="139" name="TextBox 138"/>
-          <p:cNvSpPr txBox="1"/>
-          <p:nvPr/>
-        </p:nvSpPr>
-        <p:spPr>
-          <a:xfrm>
-            <a:off x="4663440" y="1371600"/>
-            <a:ext cx="4160520" cy="246888"/>
-          </a:xfrm>
-          <a:prstGeom prst="rect">
-            <a:avLst/>
-          </a:prstGeom>
-          <a:noFill/>
-        </p:spPr>
-        <p:txBody>
-          <a:bodyPr wrap="square" anchor="t" lIns="0" rIns="0" tIns="0" bIns="0">
-            <a:noAutofit/>
-          </a:bodyPr>
-          <a:lstStyle/>
-          <a:p>
-            <a:pPr algn="l">
-              <a:spcBef>
-                <a:spcPts val="0"/>
-              </a:spcBef>
-              <a:spcAft>
-                <a:spcPts val="300"/>
-              </a:spcAft>
-            </a:pPr>
-            <a:r>
-              <a:rPr sz="1150" b="1" i="0">
-                <a:solidFill>
-                  <a:srgbClr val="202124"/>
-                </a:solidFill>
-                <a:latin typeface="Arial"/>
-              </a:rPr>
-              <a:t>The ring finding on each member</a:t>
-            </a:r>
-          </a:p>
-        </p:txBody>
-      </p:sp>
-      <p:sp>
-        <p:nvSpPr>
-          <p:cNvPr id="140" name="TextBox 139"/>
-          <p:cNvSpPr txBox="1"/>
-          <p:nvPr/>
-        </p:nvSpPr>
-        <p:spPr>
-          <a:xfrm>
-            <a:off x="4663440" y="1609344"/>
-            <a:ext cx="4160520" cy="228600"/>
-          </a:xfrm>
-          <a:prstGeom prst="rect">
-            <a:avLst/>
-          </a:prstGeom>
-          <a:noFill/>
-        </p:spPr>
-        <p:txBody>
-          <a:bodyPr wrap="square" anchor="t" lIns="0" rIns="0" tIns="0" bIns="0">
-            <a:noAutofit/>
-          </a:bodyPr>
-          <a:lstStyle/>
-          <a:p>
-            <a:pPr algn="l">
-              <a:spcBef>
-                <a:spcPts val="0"/>
-              </a:spcBef>
-              <a:spcAft>
-                <a:spcPts val="300"/>
-              </a:spcAft>
-            </a:pPr>
-            <a:r>
-              <a:rPr sz="1000" b="0" i="0">
-                <a:solidFill>
-                  <a:srgbClr val="5F6368"/>
-                </a:solidFill>
-                <a:latin typeface="Arial"/>
-              </a:rPr>
-              <a:t>Its own documents and salary rows as evidence</a:t>
-            </a:r>
-          </a:p>
-        </p:txBody>
-      </p:sp>
-      <p:pic>
-        <p:nvPicPr>
-          <p:cNvPr id="141" name="snap_r01_ring" descr="r01_ring.png"/>
-          <p:cNvPicPr>
-            <a:picLocks noChangeAspect="1"/>
-          </p:cNvPicPr>
-          <p:nvPr/>
-        </p:nvPicPr>
-        <p:blipFill>
-          <a:blip r:embed="rId5"/>
-          <a:stretch>
-            <a:fillRect/>
-          </a:stretch>
-        </p:blipFill>
-        <p:spPr>
-          <a:xfrm>
-            <a:off x="4663440" y="1920240"/>
-            <a:ext cx="4160520" cy="2418302"/>
+            <a:ext cx="4160520" cy="2661043"/>
           </a:xfrm>
           <a:prstGeom prst="rect">
             <a:avLst/>
@@ -9068,7 +8264,7 @@
                 </a:solidFill>
                 <a:latin typeface="Arial"/>
               </a:rPr>
-              <a:t>demo cases raise exactly their expected findings</a:t>
+              <a:t>demo assessments raise exactly their expected findings</a:t>
             </a:r>
           </a:p>
         </p:txBody>
@@ -9974,7 +9170,7 @@
                           </a:solidFill>
                           <a:latin typeface="Arial"/>
                         </a:rPr>
-                        <a:t>Links across applications</a:t>
+                        <a:t>Links across customers</a:t>
                       </a:r>
                     </a:p>
                   </a:txBody>
@@ -10020,7 +9216,7 @@
                           </a:solidFill>
                           <a:latin typeface="Arial"/>
                         </a:rPr>
-                        <a:t>One application at a time</a:t>
+                        <a:t>One customer at a time</a:t>
                       </a:r>
                     </a:p>
                   </a:txBody>
@@ -10066,7 +9262,7 @@
                           </a:solidFill>
                           <a:latin typeface="Arial"/>
                         </a:rPr>
-                        <a:t>Shared file, template or salary account → rings</a:t>
+                        <a:t>Shared file, account, director or contacts; GST loops</a:t>
                       </a:r>
                     </a:p>
                   </a:txBody>
@@ -10114,7 +9310,7 @@
                           </a:solidFill>
                           <a:latin typeface="Arial"/>
                         </a:rPr>
-                        <a:t>AI reliability</a:t>
+                        <a:t>Credit decision</a:t>
                       </a:r>
                     </a:p>
                   </a:txBody>
@@ -10160,7 +9356,7 @@
                           </a:solidFill>
                           <a:latin typeface="Arial"/>
                         </a:rPr>
-                        <a:t>—</a:t>
+                        <a:t>FOIR worked out by hand</a:t>
                       </a:r>
                     </a:p>
                   </a:txBody>
@@ -10206,7 +9402,7 @@
                           </a:solidFill>
                           <a:latin typeface="Arial"/>
                         </a:rPr>
-                        <a:t>Every claim cites rows; rejected claims shown</a:t>
+                        <a:t>Capacity computed in code; every AI figure traced</a:t>
                       </a:r>
                     </a:p>
                   </a:txBody>
@@ -10753,7 +9949,7 @@
                 </a:solidFill>
                 <a:latin typeface="Arial"/>
               </a:rPr>
-              <a:t>Uploaded ITR against the filed return</a:t>
+              <a:t>GST, ITR and bank turnover reconciled</a:t>
             </a:r>
           </a:p>
           <a:p>
@@ -10774,7 +9970,7 @@
                 </a:solidFill>
                 <a:latin typeface="Arial"/>
               </a:rPr>
-              <a:t>Claimed employer against the MCA register</a:t>
+              <a:t>Name, PAN and address across every source</a:t>
             </a:r>
           </a:p>
           <a:p>
@@ -10795,7 +9991,7 @@
                 </a:solidFill>
                 <a:latin typeface="Arial"/>
               </a:rPr>
-              <a:t>Edge cases: password-protected and scanned statements</a:t>
+              <a:t>Password-protected and scanned statements</a:t>
             </a:r>
           </a:p>
         </p:txBody>
@@ -11473,7 +10669,7 @@
                 </a:solidFill>
                 <a:latin typeface="Arial"/>
               </a:rPr>
-              <a:t>Entity link tables for portfolio-scale rings</a:t>
+              <a:t>Entity link tables for portfolio-scale customer links</a:t>
             </a:r>
           </a:p>
           <a:p>
@@ -11494,7 +10690,7 @@
                 </a:solidFill>
                 <a:latin typeface="Arial"/>
               </a:rPr>
-              <a:t>Findings pushed to the LOS with the loan case</a:t>
+              <a:t>Live GST, ITR and MCA through licensed providers</a:t>
             </a:r>
           </a:p>
           <a:p>
@@ -12026,7 +11222,7 @@
                 </a:solidFill>
                 <a:latin typeface="Arial"/>
               </a:rPr>
-              <a:t>Every case on the live site is synthetic: fictional banks, employers and applicants, each page stamped SYNTHETIC.</a:t>
+              <a:t>Every demo customer is synthetic: fictional businesses, banks and employers; documents stamped SYNTHETIC.</a:t>
             </a:r>
           </a:p>
         </p:txBody>
@@ -12199,7 +11395,7 @@
                 </a:solidFill>
                 <a:latin typeface="Arial"/>
               </a:rPr>
-              <a:t>README — how it works and every measurement · Doc/ARCHITECTURE.md · Doc/10_FRAUD_LENS_BUILD.md — build plan, deploy command</a:t>
+              <a:t>README — how it works and every measurement · Doc/12_CUSTOMER_RISK_LENS.md — the customer flow · Doc/ARCHITECTURE.md</a:t>
             </a:r>
           </a:p>
           <a:p>
@@ -12218,7 +11414,7 @@
                 </a:solidFill>
                 <a:latin typeface="Arial"/>
               </a:rPr>
-              <a:t>Run it yourself: dotnet test (63 tests) · DemoData eval (live extraction scored against ground truth)</a:t>
+              <a:t>Run it yourself: dotnet test (70 tests) · DemoData eval (live extraction scored against ground truth)</a:t>
             </a:r>
           </a:p>
         </p:txBody>
@@ -12387,7 +11583,7 @@
                 <a:cs typeface="Google Sans Flex Medium"/>
                 <a:sym typeface="Google Sans Flex Medium"/>
               </a:rPr>
-              <a:t>Demo cases on the live site</a:t>
+              <a:t>Demo customers on the live site</a:t>
             </a:r>
             <a:endParaRPr sz="1600">
               <a:latin typeface="Google Sans Flex Medium"/>
@@ -12408,18 +11604,18 @@
         </p:nvGraphicFramePr>
         <p:xfrm>
           <a:off x="320040" y="1188720"/>
-          <a:ext cx="8503919" cy="3570732"/>
+          <a:ext cx="8503920" cy="2688336"/>
         </p:xfrm>
         <a:graphic>
           <a:graphicData uri="http://schemas.openxmlformats.org/drawingml/2006/table">
             <a:tbl>
               <a:tblPr firstRow="1" bandRow="0"/>
               <a:tblGrid>
-                <a:gridCol w="1234440"/>
-                <a:gridCol w="3520440"/>
-                <a:gridCol w="3749039"/>
+                <a:gridCol w="1920240"/>
+                <a:gridCol w="3291840"/>
+                <a:gridCol w="3291840"/>
               </a:tblGrid>
-              <a:tr h="324612">
+              <a:tr h="384048">
                 <a:tc>
                   <a:txBody>
                     <a:bodyPr wrap="square"/>
@@ -12432,7 +11628,7 @@
                           </a:solidFill>
                           <a:latin typeface="Arial"/>
                         </a:rPr>
-                        <a:t>Case</a:t>
+                        <a:t>Customer (Udyam)</a:t>
                       </a:r>
                     </a:p>
                   </a:txBody>
@@ -12478,7 +11674,7 @@
                           </a:solidFill>
                           <a:latin typeface="Arial"/>
                         </a:rPr>
-                        <a:t>What it is</a:t>
+                        <a:t>Story</a:t>
                       </a:r>
                     </a:p>
                   </a:txBody>
@@ -12524,7 +11720,7 @@
                           </a:solidFill>
                           <a:latin typeface="Arial"/>
                         </a:rPr>
-                        <a:t>What FinRiskLens finds</a:t>
+                        <a:t>What FinRiskLens shows</a:t>
                       </a:r>
                     </a:p>
                   </a:txBody>
@@ -12559,7 +11755,7 @@
                   </a:tcPr>
                 </a:tc>
               </a:tr>
-              <a:tr h="324612">
+              <a:tr h="384048">
                 <a:tc>
                   <a:txBody>
                     <a:bodyPr wrap="square"/>
@@ -12572,7 +11768,7 @@
                           </a:solidFill>
                           <a:latin typeface="Arial"/>
                         </a:rPr>
-                        <a:t>DEMO-G01 … G05</a:t>
+                        <a:t>Clear · …-0301</a:t>
                       </a:r>
                     </a:p>
                   </a:txBody>
@@ -12618,7 +11814,7 @@
                           </a:solidFill>
                           <a:latin typeface="Arial"/>
                         </a:rPr>
-                        <a:t>Genuine applicants; G05 has Account Aggregator linked</a:t>
+                        <a:t>Consistent everywhere</a:t>
                       </a:r>
                     </a:p>
                   </a:txBody>
@@ -12664,7 +11860,7 @@
                           </a:solidFill>
                           <a:latin typeface="Arial"/>
                         </a:rPr>
-                        <a:t>Nothing — clean applicants move on</a:t>
+                        <a:t>Clear → AI credit decision → Approve → LOS</a:t>
                       </a:r>
                     </a:p>
                   </a:txBody>
@@ -12699,7 +11895,7 @@
                   </a:tcPr>
                 </a:tc>
               </a:tr>
-              <a:tr h="324612">
+              <a:tr h="384048">
                 <a:tc>
                   <a:txBody>
                     <a:bodyPr wrap="square"/>
@@ -12712,7 +11908,7 @@
                           </a:solidFill>
                           <a:latin typeface="Arial"/>
                         </a:rPr>
-                        <a:t>DEMO-T01</a:t>
+                        <a:t>Edited statement · …-0302</a:t>
                       </a:r>
                     </a:p>
                   </a:txBody>
@@ -12758,7 +11954,7 @@
                           </a:solidFill>
                           <a:latin typeface="Arial"/>
                         </a:rPr>
-                        <a:t>A receipt inflated tenfold in Word</a:t>
+                        <a:t>Uploaded statement disagrees with the bank</a:t>
                       </a:r>
                     </a:p>
                   </a:txBody>
@@ -12804,7 +12000,7 @@
                           </a:solidFill>
                           <a:latin typeface="Arial"/>
                         </a:rPr>
-                        <a:t>Balance break, totals mismatch, file edited in Word</a:t>
+                        <a:t>High risk — statement vs Account Aggregator</a:t>
                       </a:r>
                     </a:p>
                   </a:txBody>
@@ -12839,7 +12035,7 @@
                   </a:tcPr>
                 </a:tc>
               </a:tr>
-              <a:tr h="324612">
+              <a:tr h="384048">
                 <a:tc>
                   <a:txBody>
                     <a:bodyPr wrap="square"/>
@@ -12852,7 +12048,7 @@
                           </a:solidFill>
                           <a:latin typeface="Arial"/>
                         </a:rPr>
-                        <a:t>DEMO-T02</a:t>
+                        <a:t>Turnover inflation · …-0303</a:t>
                       </a:r>
                     </a:p>
                   </a:txBody>
@@ -12898,7 +12094,7 @@
                           </a:solidFill>
                           <a:latin typeface="Arial"/>
                         </a:rPr>
-                        <a:t>Page 3 swapped in from a healthier quarter</a:t>
+                        <a:t>Bank credits about 3× GST and ITR turnover</a:t>
                       </a:r>
                     </a:p>
                   </a:txBody>
@@ -12944,7 +12140,7 @@
                           </a:solidFill>
                           <a:latin typeface="Arial"/>
                         </a:rPr>
-                        <a:t>Page carry-over and balance breaks, merged in iLovePDF</a:t>
+                        <a:t>High risk — turnover mismatch across sources</a:t>
                       </a:r>
                     </a:p>
                   </a:txBody>
@@ -12979,7 +12175,7 @@
                   </a:tcPr>
                 </a:tc>
               </a:tr>
-              <a:tr h="324612">
+              <a:tr h="384048">
                 <a:tc>
                   <a:txBody>
                     <a:bodyPr wrap="square"/>
@@ -12992,7 +12188,7 @@
                           </a:solidFill>
                           <a:latin typeface="Arial"/>
                         </a:rPr>
-                        <a:t>DEMO-T03</a:t>
+                        <a:t>Edited ITR · …-0304</a:t>
                       </a:r>
                     </a:p>
                   </a:txBody>
@@ -13038,7 +12234,7 @@
                           </a:solidFill>
                           <a:latin typeface="Arial"/>
                         </a:rPr>
-                        <a:t>Salary slip with net pay typed higher, made in Canva</a:t>
+                        <a:t>Uploaded ITR shows more than the filed return</a:t>
                       </a:r>
                     </a:p>
                   </a:txBody>
@@ -13084,7 +12280,7 @@
                           </a:solidFill>
                           <a:latin typeface="Arial"/>
                         </a:rPr>
-                        <a:t>Slip arithmetic; AI: slip vs salary actually credited</a:t>
+                        <a:t>High risk — uploaded vs filed ITR</a:t>
                       </a:r>
                     </a:p>
                   </a:txBody>
@@ -13119,7 +12315,7 @@
                   </a:tcPr>
                 </a:tc>
               </a:tr>
-              <a:tr h="324612">
+              <a:tr h="384048">
                 <a:tc>
                   <a:txBody>
                     <a:bodyPr wrap="square"/>
@@ -13132,7 +12328,7 @@
                           </a:solidFill>
                           <a:latin typeface="Arial"/>
                         </a:rPr>
-                        <a:t>DEMO-T04</a:t>
+                        <a:t>Mule-like account · …-0305</a:t>
                       </a:r>
                     </a:p>
                   </a:txBody>
@@ -13178,7 +12374,7 @@
                           </a:solidFill>
                           <a:latin typeface="Arial"/>
                         </a:rPr>
-                        <a:t>Careful forgery: receipts tripled, EMIs deleted, totals recomputed</a:t>
+                        <a:t>Every receipt forwarded the same day</a:t>
                       </a:r>
                     </a:p>
                   </a:txBody>
@@ -13224,7 +12420,7 @@
                           </a:solidFill>
                           <a:latin typeface="Arial"/>
                         </a:rPr>
-                        <a:t>Statement vs the bank's Account Aggregator record</a:t>
+                        <a:t>High risk — pass-through in the bank data</a:t>
                       </a:r>
                     </a:p>
                   </a:txBody>
@@ -13259,7 +12455,7 @@
                   </a:tcPr>
                 </a:tc>
               </a:tr>
-              <a:tr h="324612">
+              <a:tr h="384048">
                 <a:tc>
                   <a:txBody>
                     <a:bodyPr wrap="square"/>
@@ -13272,7 +12468,7 @@
                           </a:solidFill>
                           <a:latin typeface="Arial"/>
                         </a:rPr>
-                        <a:t>DEMO-B01 … B03</a:t>
+                        <a:t>Circular traders · …-0306–0308</a:t>
                       </a:r>
                     </a:p>
                   </a:txBody>
@@ -13318,7 +12514,7 @@
                           </a:solidFill>
                           <a:latin typeface="Arial"/>
                         </a:rPr>
-                        <a:t>Round-tripping · window dressing · pass-through</a:t>
+                        <a:t>Invoice each other in a loop; one director</a:t>
                       </a:r>
                     </a:p>
                   </a:txBody>
@@ -13364,567 +12560,7 @@
                           </a:solidFill>
                           <a:latin typeface="Arial"/>
                         </a:rPr>
-                        <a:t>Each pattern, with the rows behind it</a:t>
-                      </a:r>
-                    </a:p>
-                  </a:txBody>
-                  <a:tcPr marL="64008" marR="64008" marT="27432" marB="27432" anchor="ctr">
-                    <a:lnL w="6350" cap="flat" cmpd="sng" algn="ctr">
-                      <a:solidFill>
-                        <a:srgbClr val="DADCE0"/>
-                      </a:solidFill>
-                      <a:prstDash val="solid"/>
-                    </a:lnL>
-                    <a:lnR w="6350" cap="flat" cmpd="sng" algn="ctr">
-                      <a:solidFill>
-                        <a:srgbClr val="DADCE0"/>
-                      </a:solidFill>
-                      <a:prstDash val="solid"/>
-                    </a:lnR>
-                    <a:lnT w="6350" cap="flat" cmpd="sng" algn="ctr">
-                      <a:solidFill>
-                        <a:srgbClr val="DADCE0"/>
-                      </a:solidFill>
-                      <a:prstDash val="solid"/>
-                    </a:lnT>
-                    <a:lnB w="6350" cap="flat" cmpd="sng" algn="ctr">
-                      <a:solidFill>
-                        <a:srgbClr val="DADCE0"/>
-                      </a:solidFill>
-                      <a:prstDash val="solid"/>
-                    </a:lnB>
-                    <a:solidFill>
-                      <a:srgbClr val="F8F9FA"/>
-                    </a:solidFill>
-                  </a:tcPr>
-                </a:tc>
-              </a:tr>
-              <a:tr h="324612">
-                <a:tc>
-                  <a:txBody>
-                    <a:bodyPr wrap="square"/>
-                    <a:lstStyle/>
-                    <a:p>
-                      <a:r>
-                        <a:rPr sz="950" b="1">
-                          <a:solidFill>
-                            <a:srgbClr val="202124"/>
-                          </a:solidFill>
-                          <a:latin typeface="Arial"/>
-                        </a:rPr>
-                        <a:t>DEMO-A01</a:t>
-                      </a:r>
-                    </a:p>
-                  </a:txBody>
-                  <a:tcPr marL="64008" marR="64008" marT="27432" marB="27432" anchor="ctr">
-                    <a:lnL w="6350" cap="flat" cmpd="sng" algn="ctr">
-                      <a:solidFill>
-                        <a:srgbClr val="DADCE0"/>
-                      </a:solidFill>
-                      <a:prstDash val="solid"/>
-                    </a:lnL>
-                    <a:lnR w="6350" cap="flat" cmpd="sng" algn="ctr">
-                      <a:solidFill>
-                        <a:srgbClr val="DADCE0"/>
-                      </a:solidFill>
-                      <a:prstDash val="solid"/>
-                    </a:lnR>
-                    <a:lnT w="6350" cap="flat" cmpd="sng" algn="ctr">
-                      <a:solidFill>
-                        <a:srgbClr val="DADCE0"/>
-                      </a:solidFill>
-                      <a:prstDash val="solid"/>
-                    </a:lnT>
-                    <a:lnB w="6350" cap="flat" cmpd="sng" algn="ctr">
-                      <a:solidFill>
-                        <a:srgbClr val="DADCE0"/>
-                      </a:solidFill>
-                      <a:prstDash val="solid"/>
-                    </a:lnB>
-                    <a:solidFill>
-                      <a:srgbClr val="FFFFFF"/>
-                    </a:solidFill>
-                  </a:tcPr>
-                </a:tc>
-                <a:tc>
-                  <a:txBody>
-                    <a:bodyPr wrap="square"/>
-                    <a:lstStyle/>
-                    <a:p>
-                      <a:r>
-                        <a:rPr sz="950" b="0">
-                          <a:solidFill>
-                            <a:srgbClr val="202124"/>
-                          </a:solidFill>
-                          <a:latin typeface="Arial"/>
-                        </a:rPr>
-                        <a:t>Monthly EMIs to two lenders never declared</a:t>
-                      </a:r>
-                    </a:p>
-                  </a:txBody>
-                  <a:tcPr marL="64008" marR="64008" marT="27432" marB="27432" anchor="ctr">
-                    <a:lnL w="6350" cap="flat" cmpd="sng" algn="ctr">
-                      <a:solidFill>
-                        <a:srgbClr val="DADCE0"/>
-                      </a:solidFill>
-                      <a:prstDash val="solid"/>
-                    </a:lnL>
-                    <a:lnR w="6350" cap="flat" cmpd="sng" algn="ctr">
-                      <a:solidFill>
-                        <a:srgbClr val="DADCE0"/>
-                      </a:solidFill>
-                      <a:prstDash val="solid"/>
-                    </a:lnR>
-                    <a:lnT w="6350" cap="flat" cmpd="sng" algn="ctr">
-                      <a:solidFill>
-                        <a:srgbClr val="DADCE0"/>
-                      </a:solidFill>
-                      <a:prstDash val="solid"/>
-                    </a:lnT>
-                    <a:lnB w="6350" cap="flat" cmpd="sng" algn="ctr">
-                      <a:solidFill>
-                        <a:srgbClr val="DADCE0"/>
-                      </a:solidFill>
-                      <a:prstDash val="solid"/>
-                    </a:lnB>
-                    <a:solidFill>
-                      <a:srgbClr val="FFFFFF"/>
-                    </a:solidFill>
-                  </a:tcPr>
-                </a:tc>
-                <a:tc>
-                  <a:txBody>
-                    <a:bodyPr wrap="square"/>
-                    <a:lstStyle/>
-                    <a:p>
-                      <a:r>
-                        <a:rPr sz="950" b="0">
-                          <a:solidFill>
-                            <a:srgbClr val="202124"/>
-                          </a:solidFill>
-                          <a:latin typeface="Arial"/>
-                        </a:rPr>
-                        <a:t>AI: undeclared EMIs, loan stacking — cited to policy</a:t>
-                      </a:r>
-                    </a:p>
-                  </a:txBody>
-                  <a:tcPr marL="64008" marR="64008" marT="27432" marB="27432" anchor="ctr">
-                    <a:lnL w="6350" cap="flat" cmpd="sng" algn="ctr">
-                      <a:solidFill>
-                        <a:srgbClr val="DADCE0"/>
-                      </a:solidFill>
-                      <a:prstDash val="solid"/>
-                    </a:lnL>
-                    <a:lnR w="6350" cap="flat" cmpd="sng" algn="ctr">
-                      <a:solidFill>
-                        <a:srgbClr val="DADCE0"/>
-                      </a:solidFill>
-                      <a:prstDash val="solid"/>
-                    </a:lnR>
-                    <a:lnT w="6350" cap="flat" cmpd="sng" algn="ctr">
-                      <a:solidFill>
-                        <a:srgbClr val="DADCE0"/>
-                      </a:solidFill>
-                      <a:prstDash val="solid"/>
-                    </a:lnT>
-                    <a:lnB w="6350" cap="flat" cmpd="sng" algn="ctr">
-                      <a:solidFill>
-                        <a:srgbClr val="DADCE0"/>
-                      </a:solidFill>
-                      <a:prstDash val="solid"/>
-                    </a:lnB>
-                    <a:solidFill>
-                      <a:srgbClr val="FFFFFF"/>
-                    </a:solidFill>
-                  </a:tcPr>
-                </a:tc>
-              </a:tr>
-              <a:tr h="324612">
-                <a:tc>
-                  <a:txBody>
-                    <a:bodyPr wrap="square"/>
-                    <a:lstStyle/>
-                    <a:p>
-                      <a:r>
-                        <a:rPr sz="950" b="1">
-                          <a:solidFill>
-                            <a:srgbClr val="202124"/>
-                          </a:solidFill>
-                          <a:latin typeface="Arial"/>
-                        </a:rPr>
-                        <a:t>DEMO-A02</a:t>
-                      </a:r>
-                    </a:p>
-                  </a:txBody>
-                  <a:tcPr marL="64008" marR="64008" marT="27432" marB="27432" anchor="ctr">
-                    <a:lnL w="6350" cap="flat" cmpd="sng" algn="ctr">
-                      <a:solidFill>
-                        <a:srgbClr val="DADCE0"/>
-                      </a:solidFill>
-                      <a:prstDash val="solid"/>
-                    </a:lnL>
-                    <a:lnR w="6350" cap="flat" cmpd="sng" algn="ctr">
-                      <a:solidFill>
-                        <a:srgbClr val="DADCE0"/>
-                      </a:solidFill>
-                      <a:prstDash val="solid"/>
-                    </a:lnR>
-                    <a:lnT w="6350" cap="flat" cmpd="sng" algn="ctr">
-                      <a:solidFill>
-                        <a:srgbClr val="DADCE0"/>
-                      </a:solidFill>
-                      <a:prstDash val="solid"/>
-                    </a:lnT>
-                    <a:lnB w="6350" cap="flat" cmpd="sng" algn="ctr">
-                      <a:solidFill>
-                        <a:srgbClr val="DADCE0"/>
-                      </a:solidFill>
-                      <a:prstDash val="solid"/>
-                    </a:lnB>
-                    <a:solidFill>
-                      <a:srgbClr val="F8F9FA"/>
-                    </a:solidFill>
-                  </a:tcPr>
-                </a:tc>
-                <a:tc>
-                  <a:txBody>
-                    <a:bodyPr wrap="square"/>
-                    <a:lstStyle/>
-                    <a:p>
-                      <a:r>
-                        <a:rPr sz="950" b="0">
-                          <a:solidFill>
-                            <a:srgbClr val="202124"/>
-                          </a:solidFill>
-                          <a:latin typeface="Arial"/>
-                        </a:rPr>
-                        <a:t>Weekly betting, monthly crypto, a bounced EMI</a:t>
-                      </a:r>
-                    </a:p>
-                  </a:txBody>
-                  <a:tcPr marL="64008" marR="64008" marT="27432" marB="27432" anchor="ctr">
-                    <a:lnL w="6350" cap="flat" cmpd="sng" algn="ctr">
-                      <a:solidFill>
-                        <a:srgbClr val="DADCE0"/>
-                      </a:solidFill>
-                      <a:prstDash val="solid"/>
-                    </a:lnL>
-                    <a:lnR w="6350" cap="flat" cmpd="sng" algn="ctr">
-                      <a:solidFill>
-                        <a:srgbClr val="DADCE0"/>
-                      </a:solidFill>
-                      <a:prstDash val="solid"/>
-                    </a:lnR>
-                    <a:lnT w="6350" cap="flat" cmpd="sng" algn="ctr">
-                      <a:solidFill>
-                        <a:srgbClr val="DADCE0"/>
-                      </a:solidFill>
-                      <a:prstDash val="solid"/>
-                    </a:lnT>
-                    <a:lnB w="6350" cap="flat" cmpd="sng" algn="ctr">
-                      <a:solidFill>
-                        <a:srgbClr val="DADCE0"/>
-                      </a:solidFill>
-                      <a:prstDash val="solid"/>
-                    </a:lnB>
-                    <a:solidFill>
-                      <a:srgbClr val="F8F9FA"/>
-                    </a:solidFill>
-                  </a:tcPr>
-                </a:tc>
-                <a:tc>
-                  <a:txBody>
-                    <a:bodyPr wrap="square"/>
-                    <a:lstStyle/>
-                    <a:p>
-                      <a:r>
-                        <a:rPr sz="950" b="0">
-                          <a:solidFill>
-                            <a:srgbClr val="202124"/>
-                          </a:solidFill>
-                          <a:latin typeface="Arial"/>
-                        </a:rPr>
-                        <a:t>AI: gambling and crypto exposure, the bounce</a:t>
-                      </a:r>
-                    </a:p>
-                  </a:txBody>
-                  <a:tcPr marL="64008" marR="64008" marT="27432" marB="27432" anchor="ctr">
-                    <a:lnL w="6350" cap="flat" cmpd="sng" algn="ctr">
-                      <a:solidFill>
-                        <a:srgbClr val="DADCE0"/>
-                      </a:solidFill>
-                      <a:prstDash val="solid"/>
-                    </a:lnL>
-                    <a:lnR w="6350" cap="flat" cmpd="sng" algn="ctr">
-                      <a:solidFill>
-                        <a:srgbClr val="DADCE0"/>
-                      </a:solidFill>
-                      <a:prstDash val="solid"/>
-                    </a:lnR>
-                    <a:lnT w="6350" cap="flat" cmpd="sng" algn="ctr">
-                      <a:solidFill>
-                        <a:srgbClr val="DADCE0"/>
-                      </a:solidFill>
-                      <a:prstDash val="solid"/>
-                    </a:lnT>
-                    <a:lnB w="6350" cap="flat" cmpd="sng" algn="ctr">
-                      <a:solidFill>
-                        <a:srgbClr val="DADCE0"/>
-                      </a:solidFill>
-                      <a:prstDash val="solid"/>
-                    </a:lnB>
-                    <a:solidFill>
-                      <a:srgbClr val="F8F9FA"/>
-                    </a:solidFill>
-                  </a:tcPr>
-                </a:tc>
-              </a:tr>
-              <a:tr h="324612">
-                <a:tc>
-                  <a:txBody>
-                    <a:bodyPr wrap="square"/>
-                    <a:lstStyle/>
-                    <a:p>
-                      <a:r>
-                        <a:rPr sz="950" b="1">
-                          <a:solidFill>
-                            <a:srgbClr val="202124"/>
-                          </a:solidFill>
-                          <a:latin typeface="Arial"/>
-                        </a:rPr>
-                        <a:t>DEMO-R01 … R04</a:t>
-                      </a:r>
-                    </a:p>
-                  </a:txBody>
-                  <a:tcPr marL="64008" marR="64008" marT="27432" marB="27432" anchor="ctr">
-                    <a:lnL w="6350" cap="flat" cmpd="sng" algn="ctr">
-                      <a:solidFill>
-                        <a:srgbClr val="DADCE0"/>
-                      </a:solidFill>
-                      <a:prstDash val="solid"/>
-                    </a:lnL>
-                    <a:lnR w="6350" cap="flat" cmpd="sng" algn="ctr">
-                      <a:solidFill>
-                        <a:srgbClr val="DADCE0"/>
-                      </a:solidFill>
-                      <a:prstDash val="solid"/>
-                    </a:lnR>
-                    <a:lnT w="6350" cap="flat" cmpd="sng" algn="ctr">
-                      <a:solidFill>
-                        <a:srgbClr val="DADCE0"/>
-                      </a:solidFill>
-                      <a:prstDash val="solid"/>
-                    </a:lnT>
-                    <a:lnB w="6350" cap="flat" cmpd="sng" algn="ctr">
-                      <a:solidFill>
-                        <a:srgbClr val="DADCE0"/>
-                      </a:solidFill>
-                      <a:prstDash val="solid"/>
-                    </a:lnB>
-                    <a:solidFill>
-                      <a:srgbClr val="FFFFFF"/>
-                    </a:solidFill>
-                  </a:tcPr>
-                </a:tc>
-                <a:tc>
-                  <a:txBody>
-                    <a:bodyPr wrap="square"/>
-                    <a:lstStyle/>
-                    <a:p>
-                      <a:r>
-                        <a:rPr sz="950" b="0">
-                          <a:solidFill>
-                            <a:srgbClr val="202124"/>
-                          </a:solidFill>
-                          <a:latin typeface="Arial"/>
-                        </a:rPr>
-                        <a:t>Four applicants from one fabricator</a:t>
-                      </a:r>
-                    </a:p>
-                  </a:txBody>
-                  <a:tcPr marL="64008" marR="64008" marT="27432" marB="27432" anchor="ctr">
-                    <a:lnL w="6350" cap="flat" cmpd="sng" algn="ctr">
-                      <a:solidFill>
-                        <a:srgbClr val="DADCE0"/>
-                      </a:solidFill>
-                      <a:prstDash val="solid"/>
-                    </a:lnL>
-                    <a:lnR w="6350" cap="flat" cmpd="sng" algn="ctr">
-                      <a:solidFill>
-                        <a:srgbClr val="DADCE0"/>
-                      </a:solidFill>
-                      <a:prstDash val="solid"/>
-                    </a:lnR>
-                    <a:lnT w="6350" cap="flat" cmpd="sng" algn="ctr">
-                      <a:solidFill>
-                        <a:srgbClr val="DADCE0"/>
-                      </a:solidFill>
-                      <a:prstDash val="solid"/>
-                    </a:lnT>
-                    <a:lnB w="6350" cap="flat" cmpd="sng" algn="ctr">
-                      <a:solidFill>
-                        <a:srgbClr val="DADCE0"/>
-                      </a:solidFill>
-                      <a:prstDash val="solid"/>
-                    </a:lnB>
-                    <a:solidFill>
-                      <a:srgbClr val="FFFFFF"/>
-                    </a:solidFill>
-                  </a:tcPr>
-                </a:tc>
-                <a:tc>
-                  <a:txBody>
-                    <a:bodyPr wrap="square"/>
-                    <a:lstStyle/>
-                    <a:p>
-                      <a:r>
-                        <a:rPr sz="950" b="0">
-                          <a:solidFill>
-                            <a:srgbClr val="202124"/>
-                          </a:solidFill>
-                          <a:latin typeface="Arial"/>
-                        </a:rPr>
-                        <a:t>A ring: one template, one salary account</a:t>
-                      </a:r>
-                    </a:p>
-                  </a:txBody>
-                  <a:tcPr marL="64008" marR="64008" marT="27432" marB="27432" anchor="ctr">
-                    <a:lnL w="6350" cap="flat" cmpd="sng" algn="ctr">
-                      <a:solidFill>
-                        <a:srgbClr val="DADCE0"/>
-                      </a:solidFill>
-                      <a:prstDash val="solid"/>
-                    </a:lnL>
-                    <a:lnR w="6350" cap="flat" cmpd="sng" algn="ctr">
-                      <a:solidFill>
-                        <a:srgbClr val="DADCE0"/>
-                      </a:solidFill>
-                      <a:prstDash val="solid"/>
-                    </a:lnR>
-                    <a:lnT w="6350" cap="flat" cmpd="sng" algn="ctr">
-                      <a:solidFill>
-                        <a:srgbClr val="DADCE0"/>
-                      </a:solidFill>
-                      <a:prstDash val="solid"/>
-                    </a:lnT>
-                    <a:lnB w="6350" cap="flat" cmpd="sng" algn="ctr">
-                      <a:solidFill>
-                        <a:srgbClr val="DADCE0"/>
-                      </a:solidFill>
-                      <a:prstDash val="solid"/>
-                    </a:lnB>
-                    <a:solidFill>
-                      <a:srgbClr val="FFFFFF"/>
-                    </a:solidFill>
-                  </a:tcPr>
-                </a:tc>
-              </a:tr>
-              <a:tr h="324612">
-                <a:tc>
-                  <a:txBody>
-                    <a:bodyPr wrap="square"/>
-                    <a:lstStyle/>
-                    <a:p>
-                      <a:r>
-                        <a:rPr sz="950" b="1">
-                          <a:solidFill>
-                            <a:srgbClr val="202124"/>
-                          </a:solidFill>
-                          <a:latin typeface="Arial"/>
-                        </a:rPr>
-                        <a:t>DEMO-R05, R06</a:t>
-                      </a:r>
-                    </a:p>
-                  </a:txBody>
-                  <a:tcPr marL="64008" marR="64008" marT="27432" marB="27432" anchor="ctr">
-                    <a:lnL w="6350" cap="flat" cmpd="sng" algn="ctr">
-                      <a:solidFill>
-                        <a:srgbClr val="DADCE0"/>
-                      </a:solidFill>
-                      <a:prstDash val="solid"/>
-                    </a:lnL>
-                    <a:lnR w="6350" cap="flat" cmpd="sng" algn="ctr">
-                      <a:solidFill>
-                        <a:srgbClr val="DADCE0"/>
-                      </a:solidFill>
-                      <a:prstDash val="solid"/>
-                    </a:lnR>
-                    <a:lnT w="6350" cap="flat" cmpd="sng" algn="ctr">
-                      <a:solidFill>
-                        <a:srgbClr val="DADCE0"/>
-                      </a:solidFill>
-                      <a:prstDash val="solid"/>
-                    </a:lnT>
-                    <a:lnB w="6350" cap="flat" cmpd="sng" algn="ctr">
-                      <a:solidFill>
-                        <a:srgbClr val="DADCE0"/>
-                      </a:solidFill>
-                      <a:prstDash val="solid"/>
-                    </a:lnB>
-                    <a:solidFill>
-                      <a:srgbClr val="F8F9FA"/>
-                    </a:solidFill>
-                  </a:tcPr>
-                </a:tc>
-                <a:tc>
-                  <a:txBody>
-                    <a:bodyPr wrap="square"/>
-                    <a:lstStyle/>
-                    <a:p>
-                      <a:r>
-                        <a:rPr sz="950" b="0">
-                          <a:solidFill>
-                            <a:srgbClr val="202124"/>
-                          </a:solidFill>
-                          <a:latin typeface="Arial"/>
-                        </a:rPr>
-                        <a:t>One statement file in two applications</a:t>
-                      </a:r>
-                    </a:p>
-                  </a:txBody>
-                  <a:tcPr marL="64008" marR="64008" marT="27432" marB="27432" anchor="ctr">
-                    <a:lnL w="6350" cap="flat" cmpd="sng" algn="ctr">
-                      <a:solidFill>
-                        <a:srgbClr val="DADCE0"/>
-                      </a:solidFill>
-                      <a:prstDash val="solid"/>
-                    </a:lnL>
-                    <a:lnR w="6350" cap="flat" cmpd="sng" algn="ctr">
-                      <a:solidFill>
-                        <a:srgbClr val="DADCE0"/>
-                      </a:solidFill>
-                      <a:prstDash val="solid"/>
-                    </a:lnR>
-                    <a:lnT w="6350" cap="flat" cmpd="sng" algn="ctr">
-                      <a:solidFill>
-                        <a:srgbClr val="DADCE0"/>
-                      </a:solidFill>
-                      <a:prstDash val="solid"/>
-                    </a:lnT>
-                    <a:lnB w="6350" cap="flat" cmpd="sng" algn="ctr">
-                      <a:solidFill>
-                        <a:srgbClr val="DADCE0"/>
-                      </a:solidFill>
-                      <a:prstDash val="solid"/>
-                    </a:lnB>
-                    <a:solidFill>
-                      <a:srgbClr val="F8F9FA"/>
-                    </a:solidFill>
-                  </a:tcPr>
-                </a:tc>
-                <a:tc>
-                  <a:txBody>
-                    <a:bodyPr wrap="square"/>
-                    <a:lstStyle/>
-                    <a:p>
-                      <a:r>
-                        <a:rPr sz="950" b="0">
-                          <a:solidFill>
-                            <a:srgbClr val="202124"/>
-                          </a:solidFill>
-                          <a:latin typeface="Arial"/>
-                        </a:rPr>
-                        <a:t>A ring: the same file, byte for byte</a:t>
+                        <a:t>High risk for all three — linked customers</a:t>
                       </a:r>
                     </a:p>
                   </a:txBody>
@@ -13963,6 +12599,57 @@
           </a:graphicData>
         </a:graphic>
       </p:graphicFrame>
+      <p:sp>
+        <p:nvSpPr>
+          <p:cNvPr id="169" name="TextBox 168"/>
+          <p:cNvSpPr txBox="1"/>
+          <p:nvPr/>
+        </p:nvSpPr>
+        <p:spPr>
+          <a:xfrm>
+            <a:off x="320040" y="4023360"/>
+            <a:ext cx="8503920" cy="274320"/>
+          </a:xfrm>
+          <a:prstGeom prst="rect">
+            <a:avLst/>
+          </a:prstGeom>
+          <a:noFill/>
+        </p:spPr>
+        <p:txBody>
+          <a:bodyPr wrap="square" anchor="t" lIns="0" rIns="0" tIns="0" bIns="0">
+            <a:noAutofit/>
+          </a:bodyPr>
+          <a:lstStyle/>
+          <a:p>
+            <a:pPr algn="l">
+              <a:spcBef>
+                <a:spcPts val="0"/>
+              </a:spcBef>
+              <a:spcAft>
+                <a:spcPts val="300"/>
+              </a:spcAft>
+            </a:pPr>
+            <a:r>
+              <a:rPr sz="950" b="1" i="0">
+                <a:solidFill>
+                  <a:srgbClr val="5F6368"/>
+                </a:solidFill>
+                <a:latin typeface="Arial"/>
+              </a:rPr>
+              <a:t>Udyam numbers </a:t>
+            </a:r>
+            <a:r>
+              <a:rPr sz="950" b="0" i="0">
+                <a:solidFill>
+                  <a:srgbClr val="5F6368"/>
+                </a:solidFill>
+                <a:latin typeface="Arial"/>
+              </a:rPr>
+              <a:t>UDYAM-MH-99-0000301 to 0000308 · bank sign-in details for the panel are on the links slide</a:t>
+            </a:r>
+          </a:p>
+        </p:txBody>
+      </p:sp>
     </p:spTree>
   </p:cSld>
   <p:clrMapOvr>
@@ -14526,7 +13213,7 @@
                 </a:solidFill>
                 <a:latin typeface="Arial"/>
               </a:rPr>
-              <a:t>Loans are decided on uploaded documents. </a:t>
+              <a:t>MSME loans are decided on shared data and uploaded documents. </a:t>
             </a:r>
             <a:r>
               <a:rPr sz="1150" b="0" i="0">
@@ -14535,7 +13222,7 @@
                 </a:solidFill>
                 <a:latin typeface="Arial"/>
               </a:rPr>
-              <a:t>A statement, salary slip or ITR can be edited in minutes, and one fabricator can supply many applicants.</a:t>
+              <a:t>A statement or ITR can be edited in minutes; one fabricator can supply many applicants.</a:t>
             </a:r>
           </a:p>
           <a:p>
@@ -14554,7 +13241,7 @@
                 </a:solidFill>
                 <a:latin typeface="Arial"/>
               </a:rPr>
-              <a:t>FinRiskLens is an AI investigator for those documents. </a:t>
+              <a:t>FinRiskLens gives the bank one fraud and risk page per customer. </a:t>
             </a:r>
             <a:r>
               <a:rPr sz="1150" b="0" i="0">
@@ -14563,7 +13250,7 @@
                 </a:solidFill>
                 <a:latin typeface="Arial"/>
               </a:rPr>
-              <a:t>It reads every page with Gemini, checks the arithmetic, compares the statement with the bank's own Account Aggregator record, links applications that share a template, file or salary account, and lets a Gemini Pro agent investigate.</a:t>
+              <a:t>Customers share bank data through Account Aggregator, fetch GST, ITR and MCA, and upload documents. Gemini reads every page, code checks the arithmetic and the bank's own record, and the network lens links related customers.</a:t>
             </a:r>
           </a:p>
           <a:p>
@@ -14582,7 +13269,7 @@
                 </a:solidFill>
                 <a:latin typeface="Arial"/>
               </a:rPr>
-              <a:t>Every finding names the risk in rupees and links to the exact row, field or page — </a:t>
+              <a:t>Every finding links to its evidence. A Clear customer gets </a:t>
             </a:r>
             <a:r>
               <a:rPr sz="1150" b="1" i="0">
@@ -14591,7 +13278,7 @@
                 </a:solidFill>
                 <a:latin typeface="Arial"/>
               </a:rPr>
-              <a:t>the credit officer confirms or dismisses it in one click.</a:t>
+              <a:t>a grounded AI credit decision, sent to the LOS, ULI (OCEN) or ONDC.</a:t>
             </a:r>
           </a:p>
         </p:txBody>
@@ -14745,7 +13432,7 @@
                 </a:solidFill>
                 <a:latin typeface="Arial"/>
               </a:rPr>
-              <a:t>The document</a:t>
+              <a:t>Every source, one page</a:t>
             </a:r>
           </a:p>
         </p:txBody>
@@ -14787,7 +13474,7 @@
                 </a:solidFill>
                 <a:latin typeface="Arial"/>
               </a:rPr>
-              <a:t>Balances, page totals, slip arithmetic and file history</a:t>
+              <a:t>Udyam, GST, bank, ITR, MCA and uploads, section by section</a:t>
             </a:r>
           </a:p>
         </p:txBody>
@@ -14983,7 +13670,7 @@
                 </a:solidFill>
                 <a:latin typeface="Arial"/>
               </a:rPr>
-              <a:t>The statement against the Account Aggregator feed</a:t>
+              <a:t>Uploaded statements against the Account Aggregator feed</a:t>
             </a:r>
           </a:p>
         </p:txBody>
@@ -15179,7 +13866,7 @@
                 </a:solidFill>
                 <a:latin typeface="Arial"/>
               </a:rPr>
-              <a:t>Shared files, templates and salary accounts form rings</a:t>
+              <a:t>Shared directors, contacts and files; circular GST trading</a:t>
             </a:r>
           </a:p>
         </p:txBody>
@@ -15333,7 +14020,7 @@
                 </a:solidFill>
                 <a:latin typeface="Arial"/>
               </a:rPr>
-              <a:t>AI judgement, grounded</a:t>
+              <a:t>Grounded AI decisions</a:t>
             </a:r>
           </a:p>
         </p:txBody>
@@ -15375,7 +14062,7 @@
                 </a:solidFill>
                 <a:latin typeface="Arial"/>
               </a:rPr>
-              <a:t>Gemini Pro investigates; every claim cites the case's rows</a:t>
+              <a:t>Investigation and credit decision; every figure traced</a:t>
             </a:r>
           </a:p>
         </p:txBody>
@@ -15765,7 +14452,7 @@
                 </a:solidFill>
                 <a:latin typeface="Arial"/>
               </a:rPr>
-              <a:t>compute metrics for one application at a time — FinRiskLens returns findings, each with its evidence</a:t>
+              <a:t>look at one document — FinRiskLens combines every source of a customer and returns findings with evidence</a:t>
             </a:r>
           </a:p>
           <a:p>
@@ -15816,7 +14503,7 @@
                 </a:solidFill>
                 <a:latin typeface="Arial"/>
               </a:rPr>
-              <a:t>Single-case review </a:t>
+              <a:t>Single-customer review </a:t>
             </a:r>
             <a:r>
               <a:rPr sz="1050" b="0" i="0">
@@ -15825,7 +14512,7 @@
                 </a:solidFill>
                 <a:latin typeface="Arial"/>
               </a:rPr>
-              <a:t>misses organised fraud — the network lens links applications into rings</a:t>
+              <a:t>misses organised fraud — the network lens links related customers</a:t>
             </a:r>
           </a:p>
         </p:txBody>
@@ -16032,7 +14719,7 @@
                 </a:solidFill>
                 <a:latin typeface="Arial"/>
               </a:rPr>
-              <a:t>a statement is read and checked in under a minute</a:t>
+              <a:t>a customer is reassessed as soon as a source arrives</a:t>
             </a:r>
           </a:p>
           <a:p>
@@ -16092,7 +14779,7 @@
                 </a:solidFill>
                 <a:latin typeface="Arial"/>
               </a:rPr>
-              <a:t>the officer confirms or dismisses each finding with a note; genuine applicants move on quickly</a:t>
+              <a:t>the officer confirms or dismisses each finding; a Clear customer goes straight to a loan case</a:t>
             </a:r>
           </a:p>
           <a:p>
@@ -16122,7 +14809,7 @@
                 </a:solidFill>
                 <a:latin typeface="Arial"/>
               </a:rPr>
-              <a:t>findings cite the lender's credit policy and fraud typology</a:t>
+              <a:t>findings and credit decisions cite the lender's credit policy</a:t>
             </a:r>
           </a:p>
         </p:txBody>
@@ -16329,7 +15016,7 @@
                 </a:solidFill>
                 <a:latin typeface="Arial"/>
               </a:rPr>
-              <a:t>a claim that cannot point to rows of the case is set aside — and shown</a:t>
+              <a:t>a claim or figure that cannot be traced is set aside — and shown</a:t>
             </a:r>
           </a:p>
           <a:p>
@@ -16380,7 +15067,7 @@
                 </a:solidFill>
                 <a:latin typeface="Arial"/>
               </a:rPr>
-              <a:t>Fraud-ring discovery </a:t>
+              <a:t>Linked customers </a:t>
             </a:r>
             <a:r>
               <a:rPr sz="1050" b="0" i="0">
@@ -16389,7 +15076,7 @@
                 </a:solidFill>
                 <a:latin typeface="Arial"/>
               </a:rPr>
-              <a:t>across every application</a:t>
+              <a:t>through directors, contacts, files and GST invoices</a:t>
             </a:r>
           </a:p>
           <a:p>
@@ -16410,7 +15097,7 @@
                 </a:solidFill>
                 <a:latin typeface="Arial"/>
               </a:rPr>
-              <a:t>Measured: </a:t>
+              <a:t>Risk to loan: </a:t>
             </a:r>
             <a:r>
               <a:rPr sz="1050" b="0" i="0">
@@ -16419,7 +15106,7 @@
                 </a:solidFill>
                 <a:latin typeface="Arial"/>
               </a:rPr>
-              <a:t>accuracy scored row by row against ground truth</a:t>
+              <a:t>AI credit decision, then LOS, ULI (OCEN) or ONDC</a:t>
             </a:r>
           </a:p>
           <a:p>
@@ -16621,7 +15308,7 @@
                 </a:solidFill>
                 <a:latin typeface="Arial"/>
               </a:rPr>
-              <a:t>Findings with evidence, ready to act on</a:t>
+              <a:t>One page per customer, findings with evidence</a:t>
             </a:r>
           </a:p>
         </p:txBody>
@@ -16705,7 +15392,7 @@
                 </a:solidFill>
                 <a:latin typeface="Arial"/>
               </a:rPr>
-              <a:t>Rings across the whole portfolio</a:t>
+              <a:t>Linked customers across the portfolio</a:t>
             </a:r>
           </a:p>
         </p:txBody>
@@ -16747,7 +15434,7 @@
                 </a:solidFill>
                 <a:latin typeface="Arial"/>
               </a:rPr>
-              <a:t>Honest applicants</a:t>
+              <a:t>Honest MSMEs</a:t>
             </a:r>
           </a:p>
         </p:txBody>
@@ -16789,7 +15476,7 @@
                 </a:solidFill>
                 <a:latin typeface="Arial"/>
               </a:rPr>
-              <a:t>No findings — a faster decision</a:t>
+              <a:t>A Clear verdict — a faster loan</a:t>
             </a:r>
           </a:p>
         </p:txBody>
@@ -17059,7 +15746,7 @@
       </p:sp>
       <p:pic>
         <p:nvPicPr>
-          <p:cNvPr id="90" name="feat_0_icon" descr="scan_w.png"/>
+          <p:cNvPr id="90" name="feat_0_icon" descr="users_w.png"/>
           <p:cNvPicPr>
             <a:picLocks noChangeAspect="1"/>
           </p:cNvPicPr>
@@ -17118,7 +15805,7 @@
                 </a:solidFill>
                 <a:latin typeface="Arial"/>
               </a:rPr>
-              <a:t>Document reading</a:t>
+              <a:t>Customer data, one place</a:t>
             </a:r>
           </a:p>
         </p:txBody>
@@ -17132,6 +15819,246 @@
         <p:spPr>
           <a:xfrm>
             <a:off x="457200" y="1792224"/>
+            <a:ext cx="2468880" cy="1088136"/>
+          </a:xfrm>
+          <a:prstGeom prst="rect">
+            <a:avLst/>
+          </a:prstGeom>
+          <a:noFill/>
+        </p:spPr>
+        <p:txBody>
+          <a:bodyPr wrap="square" anchor="t" lIns="0" rIns="0" tIns="0" bIns="0">
+            <a:noAutofit/>
+          </a:bodyPr>
+          <a:lstStyle/>
+          <a:p>
+            <a:pPr algn="l" marL="146304" indent="-146304">
+              <a:spcBef>
+                <a:spcPts val="0"/>
+              </a:spcBef>
+              <a:spcAft>
+                <a:spcPts val="300"/>
+              </a:spcAft>
+              <a:buFont typeface="Arial"/>
+              <a:buChar char="•"/>
+            </a:pPr>
+            <a:r>
+              <a:rPr sz="1000" b="0" i="0">
+                <a:solidFill>
+                  <a:srgbClr val="202124"/>
+                </a:solidFill>
+                <a:latin typeface="Arial"/>
+              </a:rPr>
+              <a:t>Udyam registration, Account Aggregator consent</a:t>
+            </a:r>
+          </a:p>
+          <a:p>
+            <a:pPr algn="l" marL="146304" indent="-146304">
+              <a:spcBef>
+                <a:spcPts val="0"/>
+              </a:spcBef>
+              <a:spcAft>
+                <a:spcPts val="300"/>
+              </a:spcAft>
+              <a:buFont typeface="Arial"/>
+              <a:buChar char="•"/>
+            </a:pPr>
+            <a:r>
+              <a:rPr sz="1000" b="0" i="0">
+                <a:solidFill>
+                  <a:srgbClr val="202124"/>
+                </a:solidFill>
+                <a:latin typeface="Arial"/>
+              </a:rPr>
+              <a:t>GST, ITR and MCA fetched; documents uploaded</a:t>
+            </a:r>
+          </a:p>
+          <a:p>
+            <a:pPr algn="l" marL="146304" indent="-146304">
+              <a:spcBef>
+                <a:spcPts val="0"/>
+              </a:spcBef>
+              <a:spcAft>
+                <a:spcPts val="300"/>
+              </a:spcAft>
+              <a:buFont typeface="Arial"/>
+              <a:buChar char="•"/>
+            </a:pPr>
+            <a:r>
+              <a:rPr sz="1000" b="0" i="0">
+                <a:solidFill>
+                  <a:srgbClr val="202124"/>
+                </a:solidFill>
+                <a:latin typeface="Arial"/>
+              </a:rPr>
+              <a:t>Reassessed whenever a source arrives</a:t>
+            </a:r>
+          </a:p>
+        </p:txBody>
+      </p:sp>
+      <p:sp>
+        <p:nvSpPr>
+          <p:cNvPr id="93" name="feat_1"/>
+          <p:cNvSpPr/>
+          <p:nvPr/>
+        </p:nvSpPr>
+        <p:spPr>
+          <a:xfrm>
+            <a:off x="3200400" y="1188720"/>
+            <a:ext cx="2743200" cy="1783080"/>
+          </a:xfrm>
+          <a:prstGeom prst="roundRect">
+            <a:avLst>
+              <a:gd name="adj" fmla="val 6000"/>
+            </a:avLst>
+          </a:prstGeom>
+          <a:solidFill>
+            <a:srgbClr val="F1F3F4"/>
+          </a:solidFill>
+          <a:ln>
+            <a:noFill/>
+          </a:ln>
+          <a:effectLst/>
+        </p:spPr>
+        <p:style>
+          <a:lnRef idx="1">
+            <a:schemeClr val="accent1"/>
+          </a:lnRef>
+          <a:fillRef idx="3">
+            <a:schemeClr val="accent1"/>
+          </a:fillRef>
+          <a:effectRef idx="2">
+            <a:schemeClr val="accent1"/>
+          </a:effectRef>
+          <a:fontRef idx="minor">
+            <a:schemeClr val="lt1"/>
+          </a:fontRef>
+        </p:style>
+        <p:txBody>
+          <a:bodyPr rtlCol="0" anchor="ctr"/>
+          <a:lstStyle/>
+          <a:p/>
+        </p:txBody>
+      </p:sp>
+      <p:sp>
+        <p:nvSpPr>
+          <p:cNvPr id="94" name="feat_1_circle"/>
+          <p:cNvSpPr/>
+          <p:nvPr/>
+        </p:nvSpPr>
+        <p:spPr>
+          <a:xfrm>
+            <a:off x="3337560" y="1325880"/>
+            <a:ext cx="384048" cy="384048"/>
+          </a:xfrm>
+          <a:prstGeom prst="ellipse">
+            <a:avLst/>
+          </a:prstGeom>
+          <a:solidFill>
+            <a:srgbClr val="7A1230"/>
+          </a:solidFill>
+          <a:ln>
+            <a:noFill/>
+          </a:ln>
+          <a:effectLst/>
+        </p:spPr>
+        <p:style>
+          <a:lnRef idx="1">
+            <a:schemeClr val="accent1"/>
+          </a:lnRef>
+          <a:fillRef idx="3">
+            <a:schemeClr val="accent1"/>
+          </a:fillRef>
+          <a:effectRef idx="2">
+            <a:schemeClr val="accent1"/>
+          </a:effectRef>
+          <a:fontRef idx="minor">
+            <a:schemeClr val="lt1"/>
+          </a:fontRef>
+        </p:style>
+        <p:txBody>
+          <a:bodyPr rtlCol="0" anchor="ctr"/>
+          <a:lstStyle/>
+          <a:p>
+            <a:pPr algn="ctr"/>
+          </a:p>
+        </p:txBody>
+      </p:sp>
+      <p:pic>
+        <p:nvPicPr>
+          <p:cNvPr id="95" name="feat_1_icon" descr="scan_w.png"/>
+          <p:cNvPicPr>
+            <a:picLocks noChangeAspect="1"/>
+          </p:cNvPicPr>
+          <p:nvPr/>
+        </p:nvPicPr>
+        <p:blipFill>
+          <a:blip r:embed="rId6"/>
+          <a:stretch>
+            <a:fillRect/>
+          </a:stretch>
+        </p:blipFill>
+        <p:spPr>
+          <a:xfrm>
+            <a:off x="3422050" y="1410370"/>
+            <a:ext cx="215066" cy="215066"/>
+          </a:xfrm>
+          <a:prstGeom prst="rect">
+            <a:avLst/>
+          </a:prstGeom>
+        </p:spPr>
+      </p:pic>
+      <p:sp>
+        <p:nvSpPr>
+          <p:cNvPr id="96" name="TextBox 95"/>
+          <p:cNvSpPr txBox="1"/>
+          <p:nvPr/>
+        </p:nvSpPr>
+        <p:spPr>
+          <a:xfrm>
+            <a:off x="3822191" y="1325880"/>
+            <a:ext cx="2011680" cy="384048"/>
+          </a:xfrm>
+          <a:prstGeom prst="rect">
+            <a:avLst/>
+          </a:prstGeom>
+          <a:noFill/>
+        </p:spPr>
+        <p:txBody>
+          <a:bodyPr wrap="square" anchor="ctr" lIns="0" rIns="0" tIns="0" bIns="0">
+            <a:noAutofit/>
+          </a:bodyPr>
+          <a:lstStyle/>
+          <a:p>
+            <a:pPr algn="l">
+              <a:spcBef>
+                <a:spcPts val="0"/>
+              </a:spcBef>
+              <a:spcAft>
+                <a:spcPts val="300"/>
+              </a:spcAft>
+            </a:pPr>
+            <a:r>
+              <a:rPr sz="1200" b="1" i="0">
+                <a:solidFill>
+                  <a:srgbClr val="202124"/>
+                </a:solidFill>
+                <a:latin typeface="Arial"/>
+              </a:rPr>
+              <a:t>Document reading</a:t>
+            </a:r>
+          </a:p>
+        </p:txBody>
+      </p:sp>
+      <p:sp>
+        <p:nvSpPr>
+          <p:cNvPr id="97" name="TextBox 96"/>
+          <p:cNvSpPr txBox="1"/>
+          <p:nvPr/>
+        </p:nvSpPr>
+        <p:spPr>
+          <a:xfrm>
+            <a:off x="3337560" y="1792224"/>
             <a:ext cx="2468880" cy="1088136"/>
           </a:xfrm>
           <a:prstGeom prst="rect">
@@ -17204,20 +16131,20 @@
                 </a:solidFill>
                 <a:latin typeface="Arial"/>
               </a:rPr>
-              <a:t>A page that does not add up is read again with more thinking</a:t>
-            </a:r>
-          </a:p>
-        </p:txBody>
-      </p:sp>
-      <p:sp>
-        <p:nvSpPr>
-          <p:cNvPr id="93" name="feat_1"/>
+              <a:t>A page that does not add up is read again</a:t>
+            </a:r>
+          </a:p>
+        </p:txBody>
+      </p:sp>
+      <p:sp>
+        <p:nvSpPr>
+          <p:cNvPr id="98" name="feat_2"/>
           <p:cNvSpPr/>
           <p:nvPr/>
         </p:nvSpPr>
         <p:spPr>
           <a:xfrm>
-            <a:off x="3200400" y="1188720"/>
+            <a:off x="6080759" y="1188720"/>
             <a:ext cx="2743200" cy="1783080"/>
           </a:xfrm>
           <a:prstGeom prst="roundRect">
@@ -17255,13 +16182,13 @@
       </p:sp>
       <p:sp>
         <p:nvSpPr>
-          <p:cNvPr id="94" name="feat_1_circle"/>
+          <p:cNvPr id="99" name="feat_2_circle"/>
           <p:cNvSpPr/>
           <p:nvPr/>
         </p:nvSpPr>
         <p:spPr>
           <a:xfrm>
-            <a:off x="3337560" y="1325880"/>
+            <a:off x="6217920" y="1325880"/>
             <a:ext cx="384048" cy="384048"/>
           </a:xfrm>
           <a:prstGeom prst="ellipse">
@@ -17299,21 +16226,21 @@
       </p:sp>
       <p:pic>
         <p:nvPicPr>
-          <p:cNvPr id="95" name="feat_1_icon" descr="calc_w.png"/>
+          <p:cNvPr id="100" name="feat_2_icon" descr="calc_w.png"/>
           <p:cNvPicPr>
             <a:picLocks noChangeAspect="1"/>
           </p:cNvPicPr>
           <p:nvPr/>
         </p:nvPicPr>
         <p:blipFill>
-          <a:blip r:embed="rId6"/>
+          <a:blip r:embed="rId7"/>
           <a:stretch>
             <a:fillRect/>
           </a:stretch>
         </p:blipFill>
         <p:spPr>
           <a:xfrm>
-            <a:off x="3422050" y="1410370"/>
+            <a:off x="6302410" y="1410370"/>
             <a:ext cx="215066" cy="215066"/>
           </a:xfrm>
           <a:prstGeom prst="rect">
@@ -17323,13 +16250,13 @@
       </p:pic>
       <p:sp>
         <p:nvSpPr>
-          <p:cNvPr id="96" name="TextBox 95"/>
+          <p:cNvPr id="101" name="TextBox 100"/>
           <p:cNvSpPr txBox="1"/>
           <p:nvPr/>
         </p:nvSpPr>
         <p:spPr>
           <a:xfrm>
-            <a:off x="3822191" y="1325880"/>
+            <a:off x="6702551" y="1325880"/>
             <a:ext cx="2011680" cy="384048"/>
           </a:xfrm>
           <a:prstGeom prst="rect">
@@ -17358,20 +16285,20 @@
                 </a:solidFill>
                 <a:latin typeface="Arial"/>
               </a:rPr>
-              <a:t>Nine deterministic checks</a:t>
-            </a:r>
-          </a:p>
-        </p:txBody>
-      </p:sp>
-      <p:sp>
-        <p:nvSpPr>
-          <p:cNvPr id="97" name="TextBox 96"/>
+              <a:t>Checks on every source</a:t>
+            </a:r>
+          </a:p>
+        </p:txBody>
+      </p:sp>
+      <p:sp>
+        <p:nvSpPr>
+          <p:cNvPr id="102" name="TextBox 101"/>
           <p:cNvSpPr txBox="1"/>
           <p:nvPr/>
         </p:nvSpPr>
         <p:spPr>
           <a:xfrm>
-            <a:off x="3337560" y="1792224"/>
+            <a:off x="6217920" y="1792224"/>
             <a:ext cx="2468880" cy="1088136"/>
           </a:xfrm>
           <a:prstGeom prst="rect">
@@ -17402,7 +16329,7 @@
                 </a:solidFill>
                 <a:latin typeface="Arial"/>
               </a:rPr>
-              <a:t>Running balance, page carry-over, stated totals</a:t>
+              <a:t>Nine checks: balances, totals, slips, file history</a:t>
             </a:r>
           </a:p>
           <a:p>
@@ -17423,7 +16350,7 @@
                 </a:solidFill>
                 <a:latin typeface="Arial"/>
               </a:rPr>
-              <a:t>Slip arithmetic, round-tripping, window dressing</a:t>
+              <a:t>Statement vs the bank's Account Aggregator record</a:t>
             </a:r>
           </a:p>
           <a:p>
@@ -17444,20 +16371,20 @@
                 </a:solidFill>
                 <a:latin typeface="Arial"/>
               </a:rPr>
-              <a:t>Pass-through, PDF file history, bank record</a:t>
-            </a:r>
-          </a:p>
-        </p:txBody>
-      </p:sp>
-      <p:sp>
-        <p:nvSpPr>
-          <p:cNvPr id="98" name="feat_2"/>
+              <a:t>Bank risk flags: pass-through, cash, bounces</a:t>
+            </a:r>
+          </a:p>
+        </p:txBody>
+      </p:sp>
+      <p:sp>
+        <p:nvSpPr>
+          <p:cNvPr id="103" name="feat_3"/>
           <p:cNvSpPr/>
           <p:nvPr/>
         </p:nvSpPr>
         <p:spPr>
           <a:xfrm>
-            <a:off x="6080759" y="1188720"/>
+            <a:off x="320040" y="3081528"/>
             <a:ext cx="2743200" cy="1783080"/>
           </a:xfrm>
           <a:prstGeom prst="roundRect">
@@ -17495,13 +16422,13 @@
       </p:sp>
       <p:sp>
         <p:nvSpPr>
-          <p:cNvPr id="99" name="feat_2_circle"/>
+          <p:cNvPr id="104" name="feat_3_circle"/>
           <p:cNvSpPr/>
           <p:nvPr/>
         </p:nvSpPr>
         <p:spPr>
           <a:xfrm>
-            <a:off x="6217920" y="1325880"/>
+            <a:off x="457200" y="3218688"/>
             <a:ext cx="384048" cy="384048"/>
           </a:xfrm>
           <a:prstGeom prst="ellipse">
@@ -17539,21 +16466,21 @@
       </p:sp>
       <p:pic>
         <p:nvPicPr>
-          <p:cNvPr id="100" name="feat_2_icon" descr="bank_w.png"/>
+          <p:cNvPr id="105" name="feat_3_icon" descr="ring_w.png"/>
           <p:cNvPicPr>
             <a:picLocks noChangeAspect="1"/>
           </p:cNvPicPr>
           <p:nvPr/>
         </p:nvPicPr>
         <p:blipFill>
-          <a:blip r:embed="rId7"/>
+          <a:blip r:embed="rId8"/>
           <a:stretch>
             <a:fillRect/>
           </a:stretch>
         </p:blipFill>
         <p:spPr>
           <a:xfrm>
-            <a:off x="6302410" y="1410370"/>
+            <a:off x="541690" y="3303178"/>
             <a:ext cx="215066" cy="215066"/>
           </a:xfrm>
           <a:prstGeom prst="rect">
@@ -17563,13 +16490,13 @@
       </p:pic>
       <p:sp>
         <p:nvSpPr>
-          <p:cNvPr id="101" name="TextBox 100"/>
+          <p:cNvPr id="106" name="TextBox 105"/>
           <p:cNvSpPr txBox="1"/>
           <p:nvPr/>
         </p:nvSpPr>
         <p:spPr>
           <a:xfrm>
-            <a:off x="6702551" y="1325880"/>
+            <a:off x="941832" y="3218688"/>
             <a:ext cx="2011680" cy="384048"/>
           </a:xfrm>
           <a:prstGeom prst="rect">
@@ -17598,20 +16525,20 @@
                 </a:solidFill>
                 <a:latin typeface="Arial"/>
               </a:rPr>
-              <a:t>Bank-record cross-check</a:t>
-            </a:r>
-          </a:p>
-        </p:txBody>
-      </p:sp>
-      <p:sp>
-        <p:nvSpPr>
-          <p:cNvPr id="102" name="TextBox 101"/>
+              <a:t>Linked customers</a:t>
+            </a:r>
+          </a:p>
+        </p:txBody>
+      </p:sp>
+      <p:sp>
+        <p:nvSpPr>
+          <p:cNvPr id="107" name="TextBox 106"/>
           <p:cNvSpPr txBox="1"/>
           <p:nvPr/>
         </p:nvSpPr>
         <p:spPr>
           <a:xfrm>
-            <a:off x="6217920" y="1792224"/>
+            <a:off x="457200" y="3685032"/>
             <a:ext cx="2468880" cy="1088136"/>
           </a:xfrm>
           <a:prstGeom prst="rect">
@@ -17642,7 +16569,7 @@
                 </a:solidFill>
                 <a:latin typeface="Arial"/>
               </a:rPr>
-              <a:t>Statement vs the bank's Account Aggregator feed</a:t>
+              <a:t>Same file, template or salary account</a:t>
             </a:r>
           </a:p>
           <a:p>
@@ -17663,7 +16590,7 @@
                 </a:solidFill>
                 <a:latin typeface="Arial"/>
               </a:rPr>
-              <a:t>Changed amounts, added and missing transactions</a:t>
+              <a:t>Same director, mobile, email or address</a:t>
             </a:r>
           </a:p>
           <a:p>
@@ -17684,20 +16611,20 @@
                 </a:solidFill>
                 <a:latin typeface="Arial"/>
               </a:rPr>
-              <a:t>Net effect on credits and debits in ₹</a:t>
-            </a:r>
-          </a:p>
-        </p:txBody>
-      </p:sp>
-      <p:sp>
-        <p:nvSpPr>
-          <p:cNvPr id="103" name="feat_3"/>
+              <a:t>Circular trading in GST invoices</a:t>
+            </a:r>
+          </a:p>
+        </p:txBody>
+      </p:sp>
+      <p:sp>
+        <p:nvSpPr>
+          <p:cNvPr id="108" name="feat_4"/>
           <p:cNvSpPr/>
           <p:nvPr/>
         </p:nvSpPr>
         <p:spPr>
           <a:xfrm>
-            <a:off x="320040" y="3081528"/>
+            <a:off x="3200400" y="3081528"/>
             <a:ext cx="2743200" cy="1783080"/>
           </a:xfrm>
           <a:prstGeom prst="roundRect">
@@ -17735,13 +16662,13 @@
       </p:sp>
       <p:sp>
         <p:nvSpPr>
-          <p:cNvPr id="104" name="feat_3_circle"/>
+          <p:cNvPr id="109" name="feat_4_circle"/>
           <p:cNvSpPr/>
           <p:nvPr/>
         </p:nvSpPr>
         <p:spPr>
           <a:xfrm>
-            <a:off x="457200" y="3218688"/>
+            <a:off x="3337560" y="3218688"/>
             <a:ext cx="384048" cy="384048"/>
           </a:xfrm>
           <a:prstGeom prst="ellipse">
@@ -17779,21 +16706,21 @@
       </p:sp>
       <p:pic>
         <p:nvPicPr>
-          <p:cNvPr id="105" name="feat_3_icon" descr="ring_w.png"/>
+          <p:cNvPr id="110" name="feat_4_icon" descr="bot_w.png"/>
           <p:cNvPicPr>
             <a:picLocks noChangeAspect="1"/>
           </p:cNvPicPr>
           <p:nvPr/>
         </p:nvPicPr>
         <p:blipFill>
-          <a:blip r:embed="rId8"/>
+          <a:blip r:embed="rId9"/>
           <a:stretch>
             <a:fillRect/>
           </a:stretch>
         </p:blipFill>
         <p:spPr>
           <a:xfrm>
-            <a:off x="541690" y="3303178"/>
+            <a:off x="3422050" y="3303178"/>
             <a:ext cx="215066" cy="215066"/>
           </a:xfrm>
           <a:prstGeom prst="rect">
@@ -17803,13 +16730,13 @@
       </p:pic>
       <p:sp>
         <p:nvSpPr>
-          <p:cNvPr id="106" name="TextBox 105"/>
+          <p:cNvPr id="111" name="TextBox 110"/>
           <p:cNvSpPr txBox="1"/>
           <p:nvPr/>
         </p:nvSpPr>
         <p:spPr>
           <a:xfrm>
-            <a:off x="941832" y="3218688"/>
+            <a:off x="3822191" y="3218688"/>
             <a:ext cx="2011680" cy="384048"/>
           </a:xfrm>
           <a:prstGeom prst="rect">
@@ -17838,20 +16765,20 @@
                 </a:solidFill>
                 <a:latin typeface="Arial"/>
               </a:rPr>
-              <a:t>Fraud-ring discovery</a:t>
-            </a:r>
-          </a:p>
-        </p:txBody>
-      </p:sp>
-      <p:sp>
-        <p:nvSpPr>
-          <p:cNvPr id="107" name="TextBox 106"/>
+              <a:t>AI investigator, grounded</a:t>
+            </a:r>
+          </a:p>
+        </p:txBody>
+      </p:sp>
+      <p:sp>
+        <p:nvSpPr>
+          <p:cNvPr id="112" name="TextBox 111"/>
           <p:cNvSpPr txBox="1"/>
           <p:nvPr/>
         </p:nvSpPr>
         <p:spPr>
           <a:xfrm>
-            <a:off x="457200" y="3685032"/>
+            <a:off x="3337560" y="3685032"/>
             <a:ext cx="2468880" cy="1088136"/>
           </a:xfrm>
           <a:prstGeom prst="rect">
@@ -17882,7 +16809,7 @@
                 </a:solidFill>
                 <a:latin typeface="Arial"/>
               </a:rPr>
-              <a:t>Same file, same template, same salary account</a:t>
+              <a:t>Gemini Pro with tools bound to one customer</a:t>
             </a:r>
           </a:p>
           <a:p>
@@ -17903,7 +16830,7 @@
                 </a:solidFill>
                 <a:latin typeface="Arial"/>
               </a:rPr>
-              <a:t>Union-find joins linked applications</a:t>
+              <a:t>Every claim cites rows; amounts must trace</a:t>
             </a:r>
           </a:p>
           <a:p>
@@ -17924,20 +16851,20 @@
                 </a:solidFill>
                 <a:latin typeface="Arial"/>
               </a:rPr>
-              <a:t>Rings page and a finding on every member</a:t>
-            </a:r>
-          </a:p>
-        </p:txBody>
-      </p:sp>
-      <p:sp>
-        <p:nvSpPr>
-          <p:cNvPr id="108" name="feat_4"/>
+              <a:t>Rejected claims shown, never hidden</a:t>
+            </a:r>
+          </a:p>
+        </p:txBody>
+      </p:sp>
+      <p:sp>
+        <p:nvSpPr>
+          <p:cNvPr id="113" name="feat_5"/>
           <p:cNvSpPr/>
           <p:nvPr/>
         </p:nvSpPr>
         <p:spPr>
           <a:xfrm>
-            <a:off x="3200400" y="3081528"/>
+            <a:off x="6080759" y="3081528"/>
             <a:ext cx="2743200" cy="1783080"/>
           </a:xfrm>
           <a:prstGeom prst="roundRect">
@@ -17975,13 +16902,13 @@
       </p:sp>
       <p:sp>
         <p:nvSpPr>
-          <p:cNvPr id="109" name="feat_4_circle"/>
+          <p:cNvPr id="114" name="feat_5_circle"/>
           <p:cNvSpPr/>
           <p:nvPr/>
         </p:nvSpPr>
         <p:spPr>
           <a:xfrm>
-            <a:off x="3337560" y="3218688"/>
+            <a:off x="6217920" y="3218688"/>
             <a:ext cx="384048" cy="384048"/>
           </a:xfrm>
           <a:prstGeom prst="ellipse">
@@ -18019,247 +16946,7 @@
       </p:sp>
       <p:pic>
         <p:nvPicPr>
-          <p:cNvPr id="110" name="feat_4_icon" descr="bot_w.png"/>
-          <p:cNvPicPr>
-            <a:picLocks noChangeAspect="1"/>
-          </p:cNvPicPr>
-          <p:nvPr/>
-        </p:nvPicPr>
-        <p:blipFill>
-          <a:blip r:embed="rId9"/>
-          <a:stretch>
-            <a:fillRect/>
-          </a:stretch>
-        </p:blipFill>
-        <p:spPr>
-          <a:xfrm>
-            <a:off x="3422050" y="3303178"/>
-            <a:ext cx="215066" cy="215066"/>
-          </a:xfrm>
-          <a:prstGeom prst="rect">
-            <a:avLst/>
-          </a:prstGeom>
-        </p:spPr>
-      </p:pic>
-      <p:sp>
-        <p:nvSpPr>
-          <p:cNvPr id="111" name="TextBox 110"/>
-          <p:cNvSpPr txBox="1"/>
-          <p:nvPr/>
-        </p:nvSpPr>
-        <p:spPr>
-          <a:xfrm>
-            <a:off x="3822191" y="3218688"/>
-            <a:ext cx="2011680" cy="384048"/>
-          </a:xfrm>
-          <a:prstGeom prst="rect">
-            <a:avLst/>
-          </a:prstGeom>
-          <a:noFill/>
-        </p:spPr>
-        <p:txBody>
-          <a:bodyPr wrap="square" anchor="ctr" lIns="0" rIns="0" tIns="0" bIns="0">
-            <a:noAutofit/>
-          </a:bodyPr>
-          <a:lstStyle/>
-          <a:p>
-            <a:pPr algn="l">
-              <a:spcBef>
-                <a:spcPts val="0"/>
-              </a:spcBef>
-              <a:spcAft>
-                <a:spcPts val="300"/>
-              </a:spcAft>
-            </a:pPr>
-            <a:r>
-              <a:rPr sz="1200" b="1" i="0">
-                <a:solidFill>
-                  <a:srgbClr val="202124"/>
-                </a:solidFill>
-                <a:latin typeface="Arial"/>
-              </a:rPr>
-              <a:t>AI investigator, grounded</a:t>
-            </a:r>
-          </a:p>
-        </p:txBody>
-      </p:sp>
-      <p:sp>
-        <p:nvSpPr>
-          <p:cNvPr id="112" name="TextBox 111"/>
-          <p:cNvSpPr txBox="1"/>
-          <p:nvPr/>
-        </p:nvSpPr>
-        <p:spPr>
-          <a:xfrm>
-            <a:off x="3337560" y="3685032"/>
-            <a:ext cx="2468880" cy="1088136"/>
-          </a:xfrm>
-          <a:prstGeom prst="rect">
-            <a:avLst/>
-          </a:prstGeom>
-          <a:noFill/>
-        </p:spPr>
-        <p:txBody>
-          <a:bodyPr wrap="square" anchor="t" lIns="0" rIns="0" tIns="0" bIns="0">
-            <a:noAutofit/>
-          </a:bodyPr>
-          <a:lstStyle/>
-          <a:p>
-            <a:pPr algn="l" marL="146304" indent="-146304">
-              <a:spcBef>
-                <a:spcPts val="0"/>
-              </a:spcBef>
-              <a:spcAft>
-                <a:spcPts val="300"/>
-              </a:spcAft>
-              <a:buFont typeface="Arial"/>
-              <a:buChar char="•"/>
-            </a:pPr>
-            <a:r>
-              <a:rPr sz="1000" b="0" i="0">
-                <a:solidFill>
-                  <a:srgbClr val="202124"/>
-                </a:solidFill>
-                <a:latin typeface="Arial"/>
-              </a:rPr>
-              <a:t>Gemini Pro with tools bound to one case</a:t>
-            </a:r>
-          </a:p>
-          <a:p>
-            <a:pPr algn="l" marL="146304" indent="-146304">
-              <a:spcBef>
-                <a:spcPts val="0"/>
-              </a:spcBef>
-              <a:spcAft>
-                <a:spcPts val="300"/>
-              </a:spcAft>
-              <a:buFont typeface="Arial"/>
-              <a:buChar char="•"/>
-            </a:pPr>
-            <a:r>
-              <a:rPr sz="1000" b="0" i="0">
-                <a:solidFill>
-                  <a:srgbClr val="202124"/>
-                </a:solidFill>
-                <a:latin typeface="Arial"/>
-              </a:rPr>
-              <a:t>Every claim cites rows; amounts must trace</a:t>
-            </a:r>
-          </a:p>
-          <a:p>
-            <a:pPr algn="l" marL="146304" indent="-146304">
-              <a:spcBef>
-                <a:spcPts val="0"/>
-              </a:spcBef>
-              <a:spcAft>
-                <a:spcPts val="300"/>
-              </a:spcAft>
-              <a:buFont typeface="Arial"/>
-              <a:buChar char="•"/>
-            </a:pPr>
-            <a:r>
-              <a:rPr sz="1000" b="0" i="0">
-                <a:solidFill>
-                  <a:srgbClr val="202124"/>
-                </a:solidFill>
-                <a:latin typeface="Arial"/>
-              </a:rPr>
-              <a:t>Rejected claims shown, never hidden</a:t>
-            </a:r>
-          </a:p>
-        </p:txBody>
-      </p:sp>
-      <p:sp>
-        <p:nvSpPr>
-          <p:cNvPr id="113" name="feat_5"/>
-          <p:cNvSpPr/>
-          <p:nvPr/>
-        </p:nvSpPr>
-        <p:spPr>
-          <a:xfrm>
-            <a:off x="6080759" y="3081528"/>
-            <a:ext cx="2743200" cy="1783080"/>
-          </a:xfrm>
-          <a:prstGeom prst="roundRect">
-            <a:avLst>
-              <a:gd name="adj" fmla="val 6000"/>
-            </a:avLst>
-          </a:prstGeom>
-          <a:solidFill>
-            <a:srgbClr val="F1F3F4"/>
-          </a:solidFill>
-          <a:ln>
-            <a:noFill/>
-          </a:ln>
-          <a:effectLst/>
-        </p:spPr>
-        <p:style>
-          <a:lnRef idx="1">
-            <a:schemeClr val="accent1"/>
-          </a:lnRef>
-          <a:fillRef idx="3">
-            <a:schemeClr val="accent1"/>
-          </a:fillRef>
-          <a:effectRef idx="2">
-            <a:schemeClr val="accent1"/>
-          </a:effectRef>
-          <a:fontRef idx="minor">
-            <a:schemeClr val="lt1"/>
-          </a:fontRef>
-        </p:style>
-        <p:txBody>
-          <a:bodyPr rtlCol="0" anchor="ctr"/>
-          <a:lstStyle/>
-          <a:p/>
-        </p:txBody>
-      </p:sp>
-      <p:sp>
-        <p:nvSpPr>
-          <p:cNvPr id="114" name="feat_5_circle"/>
-          <p:cNvSpPr/>
-          <p:nvPr/>
-        </p:nvSpPr>
-        <p:spPr>
-          <a:xfrm>
-            <a:off x="6217920" y="3218688"/>
-            <a:ext cx="384048" cy="384048"/>
-          </a:xfrm>
-          <a:prstGeom prst="ellipse">
-            <a:avLst/>
-          </a:prstGeom>
-          <a:solidFill>
-            <a:srgbClr val="7A1230"/>
-          </a:solidFill>
-          <a:ln>
-            <a:noFill/>
-          </a:ln>
-          <a:effectLst/>
-        </p:spPr>
-        <p:style>
-          <a:lnRef idx="1">
-            <a:schemeClr val="accent1"/>
-          </a:lnRef>
-          <a:fillRef idx="3">
-            <a:schemeClr val="accent1"/>
-          </a:fillRef>
-          <a:effectRef idx="2">
-            <a:schemeClr val="accent1"/>
-          </a:effectRef>
-          <a:fontRef idx="minor">
-            <a:schemeClr val="lt1"/>
-          </a:fontRef>
-        </p:style>
-        <p:txBody>
-          <a:bodyPr rtlCol="0" anchor="ctr"/>
-          <a:lstStyle/>
-          <a:p>
-            <a:pPr algn="ctr"/>
-          </a:p>
-        </p:txBody>
-      </p:sp>
-      <p:pic>
-        <p:nvPicPr>
-          <p:cNvPr id="115" name="feat_5_icon" descr="book_w.png"/>
+          <p:cNvPr id="115" name="feat_5_icon" descr="rupee_w.png"/>
           <p:cNvPicPr>
             <a:picLocks noChangeAspect="1"/>
           </p:cNvPicPr>
@@ -18318,7 +17005,7 @@
                 </a:solidFill>
                 <a:latin typeface="Arial"/>
               </a:rPr>
-              <a:t>Policy search and review</a:t>
+              <a:t>AI credit decision</a:t>
             </a:r>
           </a:p>
         </p:txBody>
@@ -18362,7 +17049,7 @@
                 </a:solidFill>
                 <a:latin typeface="Arial"/>
               </a:rPr>
-              <a:t>Hybrid search: keyword + vector + Gemini rerank</a:t>
+              <a:t>Credit capacity (FOIR) computed in code</a:t>
             </a:r>
           </a:p>
           <a:p>
@@ -18383,7 +17070,7 @@
                 </a:solidFill>
                 <a:latin typeface="Arial"/>
               </a:rPr>
-              <a:t>Findings cite the credit-policy clause</a:t>
+              <a:t>Gemini Pro decides within it, citing policy</a:t>
             </a:r>
           </a:p>
           <a:p>
@@ -18404,7 +17091,7 @@
                 </a:solidFill>
                 <a:latin typeface="Arial"/>
               </a:rPr>
-              <a:t>Confirm, dismiss, reopen with notes</a:t>
+              <a:t>Accepted decisions go to LOS, ULI or ONDC</a:t>
             </a:r>
           </a:p>
         </p:txBody>
@@ -18733,7 +17420,7 @@
                 </a:solidFill>
                 <a:latin typeface="Arial"/>
               </a:rPr>
-              <a:t>1. Ingest</a:t>
+              <a:t>1. Share</a:t>
             </a:r>
           </a:p>
         </p:txBody>
@@ -18775,7 +17462,7 @@
                 </a:solidFill>
                 <a:latin typeface="Arial"/>
               </a:rPr>
-              <a:t>Type from the bytes, SHA-256, PDF metadata</a:t>
+              <a:t>AA consent; GST, ITR, MCA; uploads</a:t>
             </a:r>
           </a:p>
         </p:txBody>
@@ -19239,7 +17926,7 @@
                 </a:solidFill>
                 <a:latin typeface="Arial"/>
               </a:rPr>
-              <a:t>Nine deterministic checks incl. bank record</a:t>
+              <a:t>Nine checks, bank record, bank risk flags</a:t>
             </a:r>
           </a:p>
         </p:txBody>
@@ -19471,7 +18158,7 @@
                 </a:solidFill>
                 <a:latin typeface="Arial"/>
               </a:rPr>
-              <a:t>Shared file, template or salary account</a:t>
+              <a:t>Directors, contacts, files, GST loops</a:t>
             </a:r>
           </a:p>
         </p:txBody>
@@ -19703,7 +18390,7 @@
                 </a:solidFill>
                 <a:latin typeface="Arial"/>
               </a:rPr>
-              <a:t>Gemini Pro agent, case-scoped tools</a:t>
+              <a:t>Gemini Pro agent; every claim verified</a:t>
             </a:r>
           </a:p>
         </p:txBody>
@@ -19834,7 +18521,7 @@
       </p:sp>
       <p:pic>
         <p:nvPicPr>
-          <p:cNvPr id="128" name="step_5_icon" descr="shield_w.png"/>
+          <p:cNvPr id="128" name="step_5_icon" descr="review_w.png"/>
           <p:cNvPicPr>
             <a:picLocks noChangeAspect="1"/>
           </p:cNvPicPr>
@@ -19893,7 +18580,7 @@
                 </a:solidFill>
                 <a:latin typeface="Arial"/>
               </a:rPr>
-              <a:t>6. Verify</a:t>
+              <a:t>6. Risk Lens</a:t>
             </a:r>
           </a:p>
         </p:txBody>
@@ -19935,7 +18622,7 @@
                 </a:solidFill>
                 <a:latin typeface="Arial"/>
               </a:rPr>
-              <a:t>Claims must cite rows; rupees must trace</a:t>
+              <a:t>Verdict per customer; officer reviews</a:t>
             </a:r>
           </a:p>
         </p:txBody>
@@ -20035,7 +18722,7 @@
             <a:avLst/>
           </a:prstGeom>
           <a:solidFill>
-            <a:srgbClr val="7A1230"/>
+            <a:srgbClr val="1A73E8"/>
           </a:solidFill>
           <a:ln>
             <a:noFill/>
@@ -20066,7 +18753,7 @@
       </p:sp>
       <p:pic>
         <p:nvPicPr>
-          <p:cNvPr id="134" name="step_6_icon" descr="review_w.png"/>
+          <p:cNvPr id="134" name="step_6_icon" descr="rupee_w.png"/>
           <p:cNvPicPr>
             <a:picLocks noChangeAspect="1"/>
           </p:cNvPicPr>
@@ -20125,7 +18812,7 @@
                 </a:solidFill>
                 <a:latin typeface="Arial"/>
               </a:rPr>
-              <a:t>7. Review</a:t>
+              <a:t>7. Decide</a:t>
             </a:r>
           </a:p>
         </p:txBody>
@@ -20167,7 +18854,7 @@
                 </a:solidFill>
                 <a:latin typeface="Arial"/>
               </a:rPr>
-              <a:t>Officer confirms or dismisses</a:t>
+              <a:t>AI credit decision → LOS · ULI · ONDC</a:t>
             </a:r>
           </a:p>
         </p:txBody>
@@ -20333,7 +19020,7 @@
       </p:sp>
       <p:pic>
         <p:nvPicPr>
-          <p:cNvPr id="140" name="actor_0_icon" descr="users_w.png"/>
+          <p:cNvPr id="140" name="actor_0_icon" descr="bank_w.png"/>
           <p:cNvPicPr>
             <a:picLocks noChangeAspect="1"/>
           </p:cNvPicPr>
@@ -20392,7 +19079,7 @@
                 </a:solidFill>
                 <a:latin typeface="Arial"/>
               </a:rPr>
-              <a:t>Credit officer</a:t>
+              <a:t>Customer (MSME)</a:t>
             </a:r>
           </a:p>
         </p:txBody>
@@ -20434,7 +19121,7 @@
                 </a:solidFill>
                 <a:latin typeface="Arial"/>
               </a:rPr>
-              <a:t>Opens a case, uploads the applicant's documents, reviews each finding with its evidence</a:t>
+              <a:t>Registers with the Udyam number, shares bank data through Account Aggregator, fetches GST, ITR and MCA, uploads documents</a:t>
             </a:r>
           </a:p>
         </p:txBody>
@@ -20531,7 +19218,7 @@
       </p:sp>
       <p:pic>
         <p:nvPicPr>
-          <p:cNvPr id="145" name="actor_1_icon" descr="bank_w.png"/>
+          <p:cNvPr id="145" name="actor_1_icon" descr="users_w.png"/>
           <p:cNvPicPr>
             <a:picLocks noChangeAspect="1"/>
           </p:cNvPicPr>
@@ -20590,7 +19277,7 @@
                 </a:solidFill>
                 <a:latin typeface="Arial"/>
               </a:rPr>
-              <a:t>Applicant (MSME)</a:t>
+              <a:t>Credit officer</a:t>
             </a:r>
           </a:p>
         </p:txBody>
@@ -20632,7 +19319,7 @@
                 </a:solidFill>
                 <a:latin typeface="Arial"/>
               </a:rPr>
-              <a:t>Shares bank data through Account Aggregator consent; GST, ITR and Udyam are fetched to verify against</a:t>
+              <a:t>One Risk Lens per customer: reviews each finding, generates and accepts the credit decision, sends the loan case</a:t>
             </a:r>
           </a:p>
         </p:txBody>
@@ -20729,7 +19416,7 @@
       </p:sp>
       <p:pic>
         <p:nvPicPr>
-          <p:cNvPr id="150" name="actor_2_icon" descr="alert_w.png"/>
+          <p:cNvPr id="150" name="actor_2_icon" descr="globe_w.png"/>
           <p:cNvPicPr>
             <a:picLocks noChangeAspect="1"/>
           </p:cNvPicPr>
@@ -20788,7 +19475,7 @@
                 </a:solidFill>
                 <a:latin typeface="Arial"/>
               </a:rPr>
-              <a:t>Fraud team</a:t>
+              <a:t>LOS · ULI · ONDC</a:t>
             </a:r>
           </a:p>
         </p:txBody>
@@ -20830,7 +19517,7 @@
                 </a:solidFill>
                 <a:latin typeface="Arial"/>
               </a:rPr>
-              <a:t>Works the Rings page: linked applications reviewed together before any is decided</a:t>
+              <a:t>Receive the accepted loan case with its risk assessment and the AI credit decision</a:t>
             </a:r>
           </a:p>
         </p:txBody>
@@ -20999,7 +19686,7 @@
                 <a:cs typeface="Google Sans Flex Medium"/>
                 <a:sym typeface="Google Sans Flex Medium"/>
               </a:rPr>
-              <a:t>Wireframe — anatomy of a finding</a:t>
+              <a:t>Wireframe — a finding on the Risk Lens</a:t>
             </a:r>
             <a:endParaRPr sz="1600">
               <a:latin typeface="Google Sans Flex Medium"/>
@@ -21314,7 +20001,7 @@
                 </a:solidFill>
                 <a:latin typeface="Arial"/>
               </a:rPr>
-              <a:t>Assess the application on the Account Aggregator data and ask the applicant to explain every difference.</a:t>
+              <a:t>Assess the customer on the Account Aggregator data and ask them to explain every difference.</a:t>
             </a:r>
           </a:p>
         </p:txBody>
@@ -21555,7 +20242,7 @@
                 </a:solidFill>
                 <a:latin typeface="Arial"/>
               </a:rPr>
-              <a:t>Note for the case file (optional)</a:t>
+              <a:t>Note for the review (optional)</a:t>
             </a:r>
           </a:p>
         </p:txBody>
@@ -22713,7 +21400,7 @@
                 </a:solidFill>
                 <a:latin typeface="Arial"/>
               </a:rPr>
-              <a:t>Confirmed and dismissed findings survive re-runs</a:t>
+              <a:t>A confirmed finding blocks the loan case; a dismissed one does not</a:t>
             </a:r>
           </a:p>
         </p:txBody>
@@ -23012,7 +21699,7 @@
                 </a:solidFill>
                 <a:latin typeface="Arial"/>
               </a:rPr>
-              <a:t>Credit officer</a:t>
+              <a:t>Customer (MSME)</a:t>
             </a:r>
           </a:p>
         </p:txBody>
@@ -23054,7 +21741,7 @@
                 </a:solidFill>
                 <a:latin typeface="Arial"/>
               </a:rPr>
-              <a:t>Bank portal: Cases · Rings · Customer 360</a:t>
+              <a:t>Registration · AA consent · fetch and upload</a:t>
             </a:r>
           </a:p>
         </p:txBody>
@@ -23178,7 +21865,7 @@
                 </a:solidFill>
                 <a:latin typeface="Arial"/>
               </a:rPr>
-              <a:t>Applicant (MSME)</a:t>
+              <a:t>Credit officer</a:t>
             </a:r>
           </a:p>
         </p:txBody>
@@ -23220,7 +21907,7 @@
                 </a:solidFill>
                 <a:latin typeface="Arial"/>
               </a:rPr>
-              <a:t>Onboarding · Account Aggregator consent</a:t>
+              <a:t>Bank portal: Customers · Risk Lens · loan case</a:t>
             </a:r>
           </a:p>
         </p:txBody>
@@ -23344,7 +22031,7 @@
                 </a:solidFill>
                 <a:latin typeface="Arial"/>
               </a:rPr>
-              <a:t>Source systems</a:t>
+              <a:t>Source and lending systems</a:t>
             </a:r>
           </a:p>
         </p:txBody>
@@ -23386,7 +22073,7 @@
                 </a:solidFill>
                 <a:latin typeface="Arial"/>
               </a:rPr>
-              <a:t>AA, GST, ITR, Udyam, MCA → ingest API</a:t>
+              <a:t>AA, GST, ITR, MCA in · LOS, ULI, ONDC out</a:t>
             </a:r>
           </a:p>
         </p:txBody>
@@ -23647,7 +22334,7 @@
                 </a:solidFill>
                 <a:latin typeface="Arial"/>
               </a:rPr>
-              <a:t>Cases, Rings, review; source-data ingest API</a:t>
+              <a:t>Customers, Risk Lens, uploads; loan-case push</a:t>
             </a:r>
           </a:p>
         </p:txBody>
@@ -23907,7 +22594,7 @@
                 </a:solidFill>
                 <a:latin typeface="Arial"/>
               </a:rPr>
-              <a:t>Nine checks; rings by union-find</a:t>
+              <a:t>Nine checks, bank flags; links between customers</a:t>
             </a:r>
           </a:p>
         </p:txBody>
@@ -24037,7 +22724,7 @@
                 </a:solidFill>
                 <a:latin typeface="Arial"/>
               </a:rPr>
-              <a:t>Function calling, 8-turn cap, case-scoped</a:t>
+              <a:t>Function calling, customer-scoped; claims verified</a:t>
             </a:r>
           </a:p>
         </p:txBody>
@@ -24125,7 +22812,7 @@
                 </a:solidFill>
                 <a:latin typeface="Arial"/>
               </a:rPr>
-              <a:t>Grounding verifier</a:t>
+              <a:t>Credit decision</a:t>
             </a:r>
           </a:p>
         </p:txBody>
@@ -24167,7 +22854,7 @@
                 </a:solidFill>
                 <a:latin typeface="Arial"/>
               </a:rPr>
-              <a:t>Rows must exist; amounts must trace</a:t>
+              <a:t>Capacity in code; Pro decides; figures verified</a:t>
             </a:r>
           </a:p>
         </p:txBody>
@@ -24566,7 +23253,7 @@
                 </a:solidFill>
                 <a:latin typeface="Arial"/>
               </a:rPr>
-              <a:t>Pro investigator, Flash rerank</a:t>
+              <a:t>Pro investigator and credit decision</a:t>
             </a:r>
           </a:p>
         </p:txBody>
@@ -24807,7 +23494,7 @@
                 </a:solidFill>
                 <a:latin typeface="Arial"/>
               </a:rPr>
-              <a:t>cases, findings,</a:t>
+              <a:t>assessments,</a:t>
             </a:r>
           </a:p>
           <a:p>
@@ -24826,7 +23513,7 @@
                 </a:solidFill>
                 <a:latin typeface="Arial"/>
               </a:rPr>
-              <a:t>evidence, knowledge chunks</a:t>
+              <a:t>findings, credit decisions, knowledge</a:t>
             </a:r>
           </a:p>
         </p:txBody>
@@ -25058,7 +23745,7 @@
                 </a:solidFill>
                 <a:latin typeface="Arial"/>
               </a:rPr>
-              <a:t>cases: </a:t>
+              <a:t>uploads</a:t>
             </a:r>
             <a:r>
               <a:rPr sz="950" b="0" i="0">
@@ -25067,7 +23754,7 @@
                 </a:solidFill>
                 <a:latin typeface="Arial"/>
               </a:rPr>
-              <a:t>uploads · </a:t>
+              <a:t> · </a:t>
             </a:r>
             <a:r>
               <a:rPr sz="950" b="1" i="0">
@@ -25486,7 +24173,7 @@
                 </a:solidFill>
                 <a:latin typeface="Arial"/>
               </a:rPr>
-              <a:t>Vertex AI — Gemini 3.5 Flash (extraction), Gemini 3.1 Pro (investigator), Gemini 3.8 Flash (rerank), gemini-embedding-001</a:t>
+              <a:t>Vertex AI — Gemini 3.5 Flash (extraction), Gemini 3.1 Pro (investigator, credit decision), Gemini 3.8 Flash (rerank), gemini-embedding-001</a:t>
             </a:r>
           </a:p>
           <a:p>
@@ -25747,7 +24434,7 @@
                 </a:solidFill>
                 <a:latin typeface="Arial"/>
               </a:rPr>
-              <a:t>Function-calling agent with tools bound server-side to one case</a:t>
+              <a:t>Function-calling agent with tools bound server-side to one customer</a:t>
             </a:r>
           </a:p>
           <a:p>
@@ -26008,7 +24695,7 @@
                 </a:solidFill>
                 <a:latin typeface="Arial"/>
               </a:rPr>
-              <a:t>PdfPig (PDF metadata and page split) · background worker on Channel&lt;T&gt;</a:t>
+              <a:t>PdfPig (PDF metadata) · background worker · LOS, ULI (OCEN) and ONDC (beckn) payloads</a:t>
             </a:r>
           </a:p>
         </p:txBody>
@@ -26227,7 +24914,7 @@
                 </a:solidFill>
                 <a:latin typeface="Arial"/>
               </a:rPr>
-              <a:t>QuestPDF synthetic cases with ground truth · 63 xUnit tests</a:t>
+              <a:t>QuestPDF synthetic documents with ground truth · 70 xUnit tests</a:t>
             </a:r>
           </a:p>
           <a:p>
@@ -26858,7 +25545,7 @@
                 </a:solidFill>
                 <a:latin typeface="Arial"/>
               </a:rPr>
-              <a:t> for one lender, about 1 lakh applications a year, on Google Cloud in Mumbai</a:t>
+              <a:t> for one lender, about 1 lakh customers assessed a year, on Google Cloud in Mumbai</a:t>
             </a:r>
           </a:p>
         </p:txBody>
@@ -27457,7 +26144,7 @@
                           </a:solidFill>
                           <a:latin typeface="Arial"/>
                         </a:rPr>
-                        <a:t>Vertex AI — Gemini extraction, investigation and embeddings</a:t>
+                        <a:t>Vertex AI — Gemini extraction, investigation, credit decisions, embeddings</a:t>
                       </a:r>
                     </a:p>
                   </a:txBody>

</xml_diff>

<commit_message>
#Docs: Oct 17 content work on the board; sample data and demo screening stated in README, architecture, deck and video
</commit_message>
<xml_diff>
--- a/Doc/FinRiskLens_AI_Builder_Cup_2026.pptx
+++ b/Doc/FinRiskLens_AI_Builder_Cup_2026.pptx
@@ -11222,7 +11222,7 @@
                 </a:solidFill>
                 <a:latin typeface="Arial"/>
               </a:rPr>
-              <a:t>Every demo customer is synthetic: fictional businesses, banks and employers; documents stamped SYNTHETIC.</a:t>
+              <a:t>All demo data is synthetic. GST, ITR and MCA are generated samples; OFAC/AML screening is a demo.</a:t>
             </a:r>
           </a:p>
         </p:txBody>
@@ -24893,7 +24893,7 @@
                 </a:solidFill>
                 <a:latin typeface="Arial"/>
               </a:rPr>
-              <a:t>Account Aggregator (Finvu) · GST · ITR · Udyam · MCA as sources of truth</a:t>
+              <a:t>Account Aggregator on the Finvu sandbox; Udyam, GST, ITR and MCA as sample data in the demo</a:t>
             </a:r>
           </a:p>
           <a:p>

</xml_diff>